<commit_message>
Add team member details
</commit_message>
<xml_diff>
--- a/slides.pptx
+++ b/slides.pptx
@@ -2,20 +2,20 @@
 <file path=ppt/presentation.xml><?xml version="1.0" encoding="utf-8"?>
 <p:presentation xmlns:p="http://schemas.openxmlformats.org/presentationml/2006/main">
   <p:sldMasterIdLst>
-    <p:sldMasterId xmlns:r="http://schemas.openxmlformats.org/officeDocument/2006/relationships" id="2147483648" r:id="Rcea6379cecb14541"/>
+    <p:sldMasterId xmlns:r="http://schemas.openxmlformats.org/officeDocument/2006/relationships" id="2147483648" r:id="R7984836083f84dbb"/>
   </p:sldMasterIdLst>
   <p:notesMasterIdLst>
-    <p:notesMasterId xmlns:r="http://schemas.openxmlformats.org/officeDocument/2006/relationships" r:id="Rf247d3f004124650"/>
+    <p:notesMasterId xmlns:r="http://schemas.openxmlformats.org/officeDocument/2006/relationships" r:id="R7794a7a12efc46a6"/>
   </p:notesMasterIdLst>
   <p:sldIdLst>
-    <p:sldId xmlns:r="http://schemas.openxmlformats.org/officeDocument/2006/relationships" id="256" r:id="Re1a71d6fba4b4b84"/>
-    <p:sldId xmlns:r="http://schemas.openxmlformats.org/officeDocument/2006/relationships" id="257" r:id="R0f06ff6c7f254fa6"/>
-    <p:sldId xmlns:r="http://schemas.openxmlformats.org/officeDocument/2006/relationships" id="258" r:id="R01bdff62d95c44e2"/>
-    <p:sldId xmlns:r="http://schemas.openxmlformats.org/officeDocument/2006/relationships" id="259" r:id="R08020f83ec0b43e2"/>
-    <p:sldId xmlns:r="http://schemas.openxmlformats.org/officeDocument/2006/relationships" id="260" r:id="R38bfb290737e4c16"/>
-    <p:sldId xmlns:r="http://schemas.openxmlformats.org/officeDocument/2006/relationships" id="261" r:id="Red4265d3418d4858"/>
-    <p:sldId xmlns:r="http://schemas.openxmlformats.org/officeDocument/2006/relationships" id="262" r:id="R5ae38ec080e14235"/>
-    <p:sldId xmlns:r="http://schemas.openxmlformats.org/officeDocument/2006/relationships" id="263" r:id="R3076cb1120b24557"/>
+    <p:sldId xmlns:r="http://schemas.openxmlformats.org/officeDocument/2006/relationships" id="256" r:id="R7379fdc9721a4d9e"/>
+    <p:sldId xmlns:r="http://schemas.openxmlformats.org/officeDocument/2006/relationships" id="257" r:id="R3bfe4520e5f04e98"/>
+    <p:sldId xmlns:r="http://schemas.openxmlformats.org/officeDocument/2006/relationships" id="258" r:id="R1600e6fa970c4bb7"/>
+    <p:sldId xmlns:r="http://schemas.openxmlformats.org/officeDocument/2006/relationships" id="259" r:id="R0f83af58fbb44419"/>
+    <p:sldId xmlns:r="http://schemas.openxmlformats.org/officeDocument/2006/relationships" id="260" r:id="R65f40c85cc4846e6"/>
+    <p:sldId xmlns:r="http://schemas.openxmlformats.org/officeDocument/2006/relationships" id="261" r:id="Rc6c21d1efd054b47"/>
+    <p:sldId xmlns:r="http://schemas.openxmlformats.org/officeDocument/2006/relationships" id="262" r:id="R8ffda08cc5f24b10"/>
+    <p:sldId xmlns:r="http://schemas.openxmlformats.org/officeDocument/2006/relationships" id="263" r:id="R3ac372af76574142"/>
   </p:sldIdLst>
   <p:sldSz cx="12192000" cy="6858000"/>
   <p:notesSz cx="6858000" cy="9144000"/>
@@ -1092,7 +1092,7 @@
   </p:cSld>
   <p:clrMap bg1="lt1" tx1="dk1" bg2="lt2" tx2="dk2" accent1="accent1" accent2="accent2" accent3="accent3" accent4="accent4" accent5="accent5" accent6="accent6" hlink="hlink" folHlink="folHlink"/>
   <p:sldLayoutIdLst>
-    <p:sldLayoutId xmlns:r="http://schemas.openxmlformats.org/officeDocument/2006/relationships" id="2147483649" r:id="R0c5c438f06214373"/>
+    <p:sldLayoutId xmlns:r="http://schemas.openxmlformats.org/officeDocument/2006/relationships" id="2147483649" r:id="R613246f32d994a14"/>
   </p:sldLayoutIdLst>
   <p:txStyles>
     <p:titleStyle>
@@ -1640,10 +1640,10 @@
       </p:grpSpPr>
       <p:sp>
         <p:nvSpPr>
-          <p:cNvPr id="12" name="">
-            <a:extLst xmlns:a="http://schemas.openxmlformats.org/drawingml/2006/main">
-              <a:ext uri="{FF2B5EF4-FFF2-40B4-BE49-F238E27FC236}">
-                <a16:creationId xmlns:a16="http://schemas.microsoft.com/office/drawing/2014/main" id="{F1F783E2-B863-46F1-BB42-D230A2F61D4A}"/>
+          <p:cNvPr id="14" name="">
+            <a:extLst xmlns:a="http://schemas.openxmlformats.org/drawingml/2006/main">
+              <a:ext uri="{FF2B5EF4-FFF2-40B4-BE49-F238E27FC236}">
+                <a16:creationId xmlns:a16="http://schemas.microsoft.com/office/drawing/2014/main" id="{DD1DF3DF-243A-4F58-B3D1-73F15704E7F6}"/>
               </a:ext>
             </a:extLst>
           </p:cNvPr>
@@ -1693,7 +1693,7 @@
           <p:cNvPr id="2" name="">
             <a:extLst xmlns:a="http://schemas.openxmlformats.org/drawingml/2006/main">
               <a:ext uri="{FF2B5EF4-FFF2-40B4-BE49-F238E27FC236}">
-                <a16:creationId xmlns:a16="http://schemas.microsoft.com/office/drawing/2014/main" id="{E72F08B8-D205-440C-9E9A-FB1C47429E41}"/>
+                <a16:creationId xmlns:a16="http://schemas.microsoft.com/office/drawing/2014/main" id="{D586E6C7-4A6B-428A-9FA4-8B4E45B350AD}"/>
               </a:ext>
             </a:extLst>
           </p:cNvPr>
@@ -1743,7 +1743,7 @@
           <p:cNvPr id="3" name="">
             <a:extLst xmlns:a="http://schemas.openxmlformats.org/drawingml/2006/main">
               <a:ext uri="{FF2B5EF4-FFF2-40B4-BE49-F238E27FC236}">
-                <a16:creationId xmlns:a16="http://schemas.microsoft.com/office/drawing/2014/main" id="{0BD25580-6449-43C1-A503-EC8D19E4582F}"/>
+                <a16:creationId xmlns:a16="http://schemas.microsoft.com/office/drawing/2014/main" id="{7A8765BB-F8A0-4C54-9C74-1973C8103715}"/>
               </a:ext>
             </a:extLst>
           </p:cNvPr>
@@ -1810,7 +1810,7 @@
           <p:cNvPr id="4" name="">
             <a:extLst xmlns:a="http://schemas.openxmlformats.org/drawingml/2006/main">
               <a:ext uri="{FF2B5EF4-FFF2-40B4-BE49-F238E27FC236}">
-                <a16:creationId xmlns:a16="http://schemas.microsoft.com/office/drawing/2014/main" id="{4DB6ED6D-BBD4-444E-982A-43DE7BA521B6}"/>
+                <a16:creationId xmlns:a16="http://schemas.microsoft.com/office/drawing/2014/main" id="{8A12262C-9A32-4D19-971C-30A71EC78B68}"/>
               </a:ext>
             </a:extLst>
           </p:cNvPr>
@@ -1841,7 +1841,7 @@
           <p:cNvPr id="5" name="">
             <a:extLst xmlns:a="http://schemas.openxmlformats.org/drawingml/2006/main">
               <a:ext uri="{FF2B5EF4-FFF2-40B4-BE49-F238E27FC236}">
-                <a16:creationId xmlns:a16="http://schemas.microsoft.com/office/drawing/2014/main" id="{51C41132-4AF8-48E6-8691-312FD40C1E35}"/>
+                <a16:creationId xmlns:a16="http://schemas.microsoft.com/office/drawing/2014/main" id="{9FC75F46-7EE0-45CD-90AA-9A65EA80D329}"/>
               </a:ext>
             </a:extLst>
           </p:cNvPr>
@@ -1891,7 +1891,7 @@
           <p:cNvPr id="6" name="">
             <a:extLst xmlns:a="http://schemas.openxmlformats.org/drawingml/2006/main">
               <a:ext uri="{FF2B5EF4-FFF2-40B4-BE49-F238E27FC236}">
-                <a16:creationId xmlns:a16="http://schemas.microsoft.com/office/drawing/2014/main" id="{91279865-207B-4E02-9ADA-6DE81CB9181E}"/>
+                <a16:creationId xmlns:a16="http://schemas.microsoft.com/office/drawing/2014/main" id="{8A2DD11A-43FE-404F-B05C-15D43DDF01CF}"/>
               </a:ext>
             </a:extLst>
           </p:cNvPr>
@@ -1922,7 +1922,7 @@
           <p:cNvPr id="7" name="">
             <a:extLst xmlns:a="http://schemas.openxmlformats.org/drawingml/2006/main">
               <a:ext uri="{FF2B5EF4-FFF2-40B4-BE49-F238E27FC236}">
-                <a16:creationId xmlns:a16="http://schemas.microsoft.com/office/drawing/2014/main" id="{856D9481-8382-4611-B772-42D0C3631345}"/>
+                <a16:creationId xmlns:a16="http://schemas.microsoft.com/office/drawing/2014/main" id="{6E4A55C9-F09C-4640-BECD-72D93342C441}"/>
               </a:ext>
             </a:extLst>
           </p:cNvPr>
@@ -1972,7 +1972,7 @@
           <p:cNvPr id="8" name="">
             <a:extLst xmlns:a="http://schemas.openxmlformats.org/drawingml/2006/main">
               <a:ext uri="{FF2B5EF4-FFF2-40B4-BE49-F238E27FC236}">
-                <a16:creationId xmlns:a16="http://schemas.microsoft.com/office/drawing/2014/main" id="{86AED8B4-F703-4547-89BA-208EAC279841}"/>
+                <a16:creationId xmlns:a16="http://schemas.microsoft.com/office/drawing/2014/main" id="{F65EE3EA-2A65-4AEB-A18E-1B558FDAF67D}"/>
               </a:ext>
             </a:extLst>
           </p:cNvPr>
@@ -2022,7 +2022,7 @@
           <p:cNvPr id="9" name="">
             <a:extLst xmlns:a="http://schemas.openxmlformats.org/drawingml/2006/main">
               <a:ext uri="{FF2B5EF4-FFF2-40B4-BE49-F238E27FC236}">
-                <a16:creationId xmlns:a16="http://schemas.microsoft.com/office/drawing/2014/main" id="{9FDA65E5-9B99-4C27-805A-76A38FD43212}"/>
+                <a16:creationId xmlns:a16="http://schemas.microsoft.com/office/drawing/2014/main" id="{39752889-06B4-44BE-B4DC-02DD1B19974F}"/>
               </a:ext>
             </a:extLst>
           </p:cNvPr>
@@ -2072,7 +2072,7 @@
           <p:cNvPr id="10" name="">
             <a:extLst xmlns:a="http://schemas.openxmlformats.org/drawingml/2006/main">
               <a:ext uri="{FF2B5EF4-FFF2-40B4-BE49-F238E27FC236}">
-                <a16:creationId xmlns:a16="http://schemas.microsoft.com/office/drawing/2014/main" id="{4D18CD3D-AF6A-4529-ABBB-FABC53097E3C}"/>
+                <a16:creationId xmlns:a16="http://schemas.microsoft.com/office/drawing/2014/main" id="{4CD4ADE6-510F-407B-B190-48509BB2CFAC}"/>
               </a:ext>
             </a:extLst>
           </p:cNvPr>
@@ -2122,47 +2122,147 @@
           <p:cNvPr id="11" name="">
             <a:extLst xmlns:a="http://schemas.openxmlformats.org/drawingml/2006/main">
               <a:ext uri="{FF2B5EF4-FFF2-40B4-BE49-F238E27FC236}">
-                <a16:creationId xmlns:a16="http://schemas.microsoft.com/office/drawing/2014/main" id="{55B6F063-8331-4065-80DB-5B8B9A64F82B}"/>
-              </a:ext>
-            </a:extLst>
-          </p:cNvPr>
-          <p:cNvSpPr>
-            <a:spLocks xmlns:a="http://schemas.openxmlformats.org/drawingml/2006/main" noGrp="1"/>
-          </p:cNvSpPr>
-          <p:nvPr/>
-        </p:nvSpPr>
-        <p:spPr>
-          <a:xfrm xmlns:a="http://schemas.openxmlformats.org/drawingml/2006/main">
-            <a:off x="685800" y="6038850"/>
-            <a:ext cx="6191250" cy="266700"/>
-          </a:xfrm>
-          <a:prstGeom xmlns:a="http://schemas.openxmlformats.org/drawingml/2006/main" prst="rect">
-            <a:avLst/>
-          </a:prstGeom>
-          <a:noFill xmlns:a="http://schemas.openxmlformats.org/drawingml/2006/main"/>
-          <a:ln xmlns:a="http://schemas.openxmlformats.org/drawingml/2006/main" w="0">
-            <a:noFill/>
-            <a:prstDash val="solid"/>
-          </a:ln>
-        </p:spPr>
-        <p:txBody>
-          <a:bodyPr xmlns:a="http://schemas.openxmlformats.org/drawingml/2006/main" anchor="ctr"/>
-          <a:lstStyle xmlns:a="http://schemas.openxmlformats.org/drawingml/2006/main"/>
-          <a:p xmlns:a="http://schemas.openxmlformats.org/drawingml/2006/main">
-            <a:pPr algn="l">
-              <a:defRPr sz="1200" b="0">
+                <a16:creationId xmlns:a16="http://schemas.microsoft.com/office/drawing/2014/main" id="{448DD2D6-4740-46FE-8ACD-FE17C29C2F6A}"/>
+              </a:ext>
+            </a:extLst>
+          </p:cNvPr>
+          <p:cNvSpPr>
+            <a:spLocks xmlns:a="http://schemas.openxmlformats.org/drawingml/2006/main" noGrp="1"/>
+          </p:cNvSpPr>
+          <p:nvPr/>
+        </p:nvSpPr>
+        <p:spPr>
+          <a:xfrm xmlns:a="http://schemas.openxmlformats.org/drawingml/2006/main">
+            <a:off x="685800" y="5753100"/>
+            <a:ext cx="6191250" cy="209550"/>
+          </a:xfrm>
+          <a:prstGeom xmlns:a="http://schemas.openxmlformats.org/drawingml/2006/main" prst="rect">
+            <a:avLst/>
+          </a:prstGeom>
+          <a:noFill xmlns:a="http://schemas.openxmlformats.org/drawingml/2006/main"/>
+          <a:ln xmlns:a="http://schemas.openxmlformats.org/drawingml/2006/main" w="0">
+            <a:noFill/>
+            <a:prstDash val="solid"/>
+          </a:ln>
+        </p:spPr>
+        <p:txBody>
+          <a:bodyPr xmlns:a="http://schemas.openxmlformats.org/drawingml/2006/main" anchor="ctr"/>
+          <a:lstStyle xmlns:a="http://schemas.openxmlformats.org/drawingml/2006/main"/>
+          <a:p xmlns:a="http://schemas.openxmlformats.org/drawingml/2006/main">
+            <a:pPr algn="l">
+              <a:defRPr sz="975" b="0">
                 <a:solidFill>
                   <a:srgbClr val="63666A"/>
                 </a:solidFill>
               </a:defRPr>
             </a:pPr>
             <a:r>
-              <a:rPr sz="1200" b="0">
+              <a:rPr sz="975" b="0">
                 <a:solidFill>
                   <a:srgbClr val="63666A"/>
                 </a:solidFill>
               </a:rPr>
-              <a:t>Cập nhật 14.08.2026  ·  Nhóm: Chưa cập nhật</a:t>
+              <a:t>Nhóm 5 · Leader: Nguyễn Tấn Hoàng — 2A202601198</a:t>
+            </a:r>
+          </a:p>
+        </p:txBody>
+      </p:sp>
+      <p:sp>
+        <p:nvSpPr>
+          <p:cNvPr id="12" name="">
+            <a:extLst xmlns:a="http://schemas.openxmlformats.org/drawingml/2006/main">
+              <a:ext uri="{FF2B5EF4-FFF2-40B4-BE49-F238E27FC236}">
+                <a16:creationId xmlns:a16="http://schemas.microsoft.com/office/drawing/2014/main" id="{166DEC5B-63B5-4199-8DF1-089D819452B8}"/>
+              </a:ext>
+            </a:extLst>
+          </p:cNvPr>
+          <p:cNvSpPr>
+            <a:spLocks xmlns:a="http://schemas.openxmlformats.org/drawingml/2006/main" noGrp="1"/>
+          </p:cNvSpPr>
+          <p:nvPr/>
+        </p:nvSpPr>
+        <p:spPr>
+          <a:xfrm xmlns:a="http://schemas.openxmlformats.org/drawingml/2006/main">
+            <a:off x="685800" y="5972175"/>
+            <a:ext cx="6191250" cy="190500"/>
+          </a:xfrm>
+          <a:prstGeom xmlns:a="http://schemas.openxmlformats.org/drawingml/2006/main" prst="rect">
+            <a:avLst/>
+          </a:prstGeom>
+          <a:noFill xmlns:a="http://schemas.openxmlformats.org/drawingml/2006/main"/>
+          <a:ln xmlns:a="http://schemas.openxmlformats.org/drawingml/2006/main" w="0">
+            <a:noFill/>
+            <a:prstDash val="solid"/>
+          </a:ln>
+        </p:spPr>
+        <p:txBody>
+          <a:bodyPr xmlns:a="http://schemas.openxmlformats.org/drawingml/2006/main" anchor="ctr"/>
+          <a:lstStyle xmlns:a="http://schemas.openxmlformats.org/drawingml/2006/main"/>
+          <a:p xmlns:a="http://schemas.openxmlformats.org/drawingml/2006/main">
+            <a:pPr algn="l">
+              <a:defRPr sz="900" b="0">
+                <a:solidFill>
+                  <a:srgbClr val="63666A"/>
+                </a:solidFill>
+              </a:defRPr>
+            </a:pPr>
+            <a:r>
+              <a:rPr sz="900" b="0">
+                <a:solidFill>
+                  <a:srgbClr val="63666A"/>
+                </a:solidFill>
+              </a:rPr>
+              <a:t>Nguyễn Minh Đức — 2A202601946 · Đỗ Tú Anh — 2A202601272</a:t>
+            </a:r>
+          </a:p>
+        </p:txBody>
+      </p:sp>
+      <p:sp>
+        <p:nvSpPr>
+          <p:cNvPr id="13" name="">
+            <a:extLst xmlns:a="http://schemas.openxmlformats.org/drawingml/2006/main">
+              <a:ext uri="{FF2B5EF4-FFF2-40B4-BE49-F238E27FC236}">
+                <a16:creationId xmlns:a16="http://schemas.microsoft.com/office/drawing/2014/main" id="{0A1BA552-9432-4D38-8344-3A8CF90D2446}"/>
+              </a:ext>
+            </a:extLst>
+          </p:cNvPr>
+          <p:cNvSpPr>
+            <a:spLocks xmlns:a="http://schemas.openxmlformats.org/drawingml/2006/main" noGrp="1"/>
+          </p:cNvSpPr>
+          <p:nvPr/>
+        </p:nvSpPr>
+        <p:spPr>
+          <a:xfrm xmlns:a="http://schemas.openxmlformats.org/drawingml/2006/main">
+            <a:off x="685800" y="6172200"/>
+            <a:ext cx="6667500" cy="190500"/>
+          </a:xfrm>
+          <a:prstGeom xmlns:a="http://schemas.openxmlformats.org/drawingml/2006/main" prst="rect">
+            <a:avLst/>
+          </a:prstGeom>
+          <a:noFill xmlns:a="http://schemas.openxmlformats.org/drawingml/2006/main"/>
+          <a:ln xmlns:a="http://schemas.openxmlformats.org/drawingml/2006/main" w="0">
+            <a:noFill/>
+            <a:prstDash val="solid"/>
+          </a:ln>
+        </p:spPr>
+        <p:txBody>
+          <a:bodyPr xmlns:a="http://schemas.openxmlformats.org/drawingml/2006/main" anchor="ctr"/>
+          <a:lstStyle xmlns:a="http://schemas.openxmlformats.org/drawingml/2006/main"/>
+          <a:p xmlns:a="http://schemas.openxmlformats.org/drawingml/2006/main">
+            <a:pPr algn="l">
+              <a:defRPr sz="900" b="0">
+                <a:solidFill>
+                  <a:srgbClr val="63666A"/>
+                </a:solidFill>
+              </a:defRPr>
+            </a:pPr>
+            <a:r>
+              <a:rPr sz="900" b="0">
+                <a:solidFill>
+                  <a:srgbClr val="63666A"/>
+                </a:solidFill>
+              </a:rPr>
+              <a:t>Trần Hoàng Quân — 2A202601805 · Trần Thị Hoa Mai — 2A202601317</a:t>
             </a:r>
           </a:p>
         </p:txBody>
@@ -2170,7 +2270,7 @@
     </p:spTree>
     <p:extLst>
       <p:ext uri="{BB962C8B-B14F-4D97-AF65-F5344CB8AC3E}">
-        <p14:creationId xmlns:p14="http://schemas.microsoft.com/office/powerpoint/2010/main" val="1851370182"/>
+        <p14:creationId xmlns:p14="http://schemas.microsoft.com/office/powerpoint/2010/main" val="1489125374"/>
       </p:ext>
     </p:extLst>
   </p:cSld>
@@ -2201,7 +2301,7 @@
           <p:cNvPr id="48" name="">
             <a:extLst xmlns:a="http://schemas.openxmlformats.org/drawingml/2006/main">
               <a:ext uri="{FF2B5EF4-FFF2-40B4-BE49-F238E27FC236}">
-                <a16:creationId xmlns:a16="http://schemas.microsoft.com/office/drawing/2014/main" id="{0400EF2F-30A1-4514-A0BE-E21BBA2A5B42}"/>
+                <a16:creationId xmlns:a16="http://schemas.microsoft.com/office/drawing/2014/main" id="{54D9E403-9C43-4CFB-A76D-EE57A432A5A9}"/>
               </a:ext>
             </a:extLst>
           </p:cNvPr>
@@ -2251,7 +2351,7 @@
           <p:cNvPr id="2" name="">
             <a:extLst xmlns:a="http://schemas.openxmlformats.org/drawingml/2006/main">
               <a:ext uri="{FF2B5EF4-FFF2-40B4-BE49-F238E27FC236}">
-                <a16:creationId xmlns:a16="http://schemas.microsoft.com/office/drawing/2014/main" id="{1826F0DA-82D9-48F4-A7D4-2AF9836AA815}"/>
+                <a16:creationId xmlns:a16="http://schemas.microsoft.com/office/drawing/2014/main" id="{9B0C2679-5D8D-4683-95CD-E204F689CF92}"/>
               </a:ext>
             </a:extLst>
           </p:cNvPr>
@@ -2301,7 +2401,7 @@
           <p:cNvPr id="3" name="">
             <a:extLst xmlns:a="http://schemas.openxmlformats.org/drawingml/2006/main">
               <a:ext uri="{FF2B5EF4-FFF2-40B4-BE49-F238E27FC236}">
-                <a16:creationId xmlns:a16="http://schemas.microsoft.com/office/drawing/2014/main" id="{EB195D65-6480-4300-BE7E-5EC29D3035FA}"/>
+                <a16:creationId xmlns:a16="http://schemas.microsoft.com/office/drawing/2014/main" id="{13DD4861-9CE0-44A8-84B6-09B0E159DA5F}"/>
               </a:ext>
             </a:extLst>
           </p:cNvPr>
@@ -2351,7 +2451,7 @@
           <p:cNvPr id="4" name="">
             <a:extLst xmlns:a="http://schemas.openxmlformats.org/drawingml/2006/main">
               <a:ext uri="{FF2B5EF4-FFF2-40B4-BE49-F238E27FC236}">
-                <a16:creationId xmlns:a16="http://schemas.microsoft.com/office/drawing/2014/main" id="{4355FEBC-3043-45BC-9F9B-6D8CAAF61CCB}"/>
+                <a16:creationId xmlns:a16="http://schemas.microsoft.com/office/drawing/2014/main" id="{8FB3EBDA-9ABF-4F73-B8B7-79C904590B52}"/>
               </a:ext>
             </a:extLst>
           </p:cNvPr>
@@ -2382,7 +2482,7 @@
           <p:cNvPr id="5" name="">
             <a:extLst xmlns:a="http://schemas.openxmlformats.org/drawingml/2006/main">
               <a:ext uri="{FF2B5EF4-FFF2-40B4-BE49-F238E27FC236}">
-                <a16:creationId xmlns:a16="http://schemas.microsoft.com/office/drawing/2014/main" id="{0DE501B5-9E48-40D4-A913-259577A6145A}"/>
+                <a16:creationId xmlns:a16="http://schemas.microsoft.com/office/drawing/2014/main" id="{3A439D59-2F33-4FD3-B91A-9B5118D13024}"/>
               </a:ext>
             </a:extLst>
           </p:cNvPr>
@@ -2413,7 +2513,7 @@
           <p:cNvPr id="6" name="">
             <a:extLst xmlns:a="http://schemas.openxmlformats.org/drawingml/2006/main">
               <a:ext uri="{FF2B5EF4-FFF2-40B4-BE49-F238E27FC236}">
-                <a16:creationId xmlns:a16="http://schemas.microsoft.com/office/drawing/2014/main" id="{114B5251-4F98-4E85-9D1B-3AC1FC467164}"/>
+                <a16:creationId xmlns:a16="http://schemas.microsoft.com/office/drawing/2014/main" id="{31653735-A05A-4DCF-80A9-DBA45C558325}"/>
               </a:ext>
             </a:extLst>
           </p:cNvPr>
@@ -2444,7 +2544,7 @@
           <p:cNvPr id="7" name="">
             <a:extLst xmlns:a="http://schemas.openxmlformats.org/drawingml/2006/main">
               <a:ext uri="{FF2B5EF4-FFF2-40B4-BE49-F238E27FC236}">
-                <a16:creationId xmlns:a16="http://schemas.microsoft.com/office/drawing/2014/main" id="{47608368-EC85-4671-B22C-74CBAB04B62B}"/>
+                <a16:creationId xmlns:a16="http://schemas.microsoft.com/office/drawing/2014/main" id="{F862E454-87E9-4921-B8F5-5A2D09088E44}"/>
               </a:ext>
             </a:extLst>
           </p:cNvPr>
@@ -2494,7 +2594,7 @@
           <p:cNvPr id="8" name="">
             <a:extLst xmlns:a="http://schemas.openxmlformats.org/drawingml/2006/main">
               <a:ext uri="{FF2B5EF4-FFF2-40B4-BE49-F238E27FC236}">
-                <a16:creationId xmlns:a16="http://schemas.microsoft.com/office/drawing/2014/main" id="{C5E12729-6357-4D71-A98D-4CCF40A97683}"/>
+                <a16:creationId xmlns:a16="http://schemas.microsoft.com/office/drawing/2014/main" id="{C37A3197-D9A3-4909-A75C-33755A118689}"/>
               </a:ext>
             </a:extLst>
           </p:cNvPr>
@@ -2525,7 +2625,7 @@
           <p:cNvPr id="9" name="">
             <a:extLst xmlns:a="http://schemas.openxmlformats.org/drawingml/2006/main">
               <a:ext uri="{FF2B5EF4-FFF2-40B4-BE49-F238E27FC236}">
-                <a16:creationId xmlns:a16="http://schemas.microsoft.com/office/drawing/2014/main" id="{A894C1B0-7369-4CD2-A256-E6A5C8684917}"/>
+                <a16:creationId xmlns:a16="http://schemas.microsoft.com/office/drawing/2014/main" id="{D4FCEF00-70F6-481F-9582-6B221C5D7BFD}"/>
               </a:ext>
             </a:extLst>
           </p:cNvPr>
@@ -2575,7 +2675,7 @@
           <p:cNvPr id="10" name="">
             <a:extLst xmlns:a="http://schemas.openxmlformats.org/drawingml/2006/main">
               <a:ext uri="{FF2B5EF4-FFF2-40B4-BE49-F238E27FC236}">
-                <a16:creationId xmlns:a16="http://schemas.microsoft.com/office/drawing/2014/main" id="{161EF1A1-C511-47C1-8D4D-80EBE1AAF4A8}"/>
+                <a16:creationId xmlns:a16="http://schemas.microsoft.com/office/drawing/2014/main" id="{A1045CDB-B923-4A69-B217-65F97C9FA39E}"/>
               </a:ext>
             </a:extLst>
           </p:cNvPr>
@@ -2606,7 +2706,7 @@
           <p:cNvPr id="11" name="">
             <a:extLst xmlns:a="http://schemas.openxmlformats.org/drawingml/2006/main">
               <a:ext uri="{FF2B5EF4-FFF2-40B4-BE49-F238E27FC236}">
-                <a16:creationId xmlns:a16="http://schemas.microsoft.com/office/drawing/2014/main" id="{3A8DB577-E968-42D7-81BC-BAFE26209815}"/>
+                <a16:creationId xmlns:a16="http://schemas.microsoft.com/office/drawing/2014/main" id="{266CA600-FAF5-46CB-A329-C02A6C46F3A7}"/>
               </a:ext>
             </a:extLst>
           </p:cNvPr>
@@ -2656,7 +2756,7 @@
           <p:cNvPr id="12" name="">
             <a:extLst xmlns:a="http://schemas.openxmlformats.org/drawingml/2006/main">
               <a:ext uri="{FF2B5EF4-FFF2-40B4-BE49-F238E27FC236}">
-                <a16:creationId xmlns:a16="http://schemas.microsoft.com/office/drawing/2014/main" id="{590DD1F6-7304-4A1F-AFF0-EB6987FDA305}"/>
+                <a16:creationId xmlns:a16="http://schemas.microsoft.com/office/drawing/2014/main" id="{F985896C-ABBF-4C19-BBB2-46955B60A73A}"/>
               </a:ext>
             </a:extLst>
           </p:cNvPr>
@@ -2687,7 +2787,7 @@
           <p:cNvPr id="13" name="">
             <a:extLst xmlns:a="http://schemas.openxmlformats.org/drawingml/2006/main">
               <a:ext uri="{FF2B5EF4-FFF2-40B4-BE49-F238E27FC236}">
-                <a16:creationId xmlns:a16="http://schemas.microsoft.com/office/drawing/2014/main" id="{CBB774D9-AD6E-4FCA-B107-B41A6B05AA77}"/>
+                <a16:creationId xmlns:a16="http://schemas.microsoft.com/office/drawing/2014/main" id="{92FE1981-8270-45AD-9753-0EAF692E0313}"/>
               </a:ext>
             </a:extLst>
           </p:cNvPr>
@@ -2737,7 +2837,7 @@
           <p:cNvPr id="14" name="">
             <a:extLst xmlns:a="http://schemas.openxmlformats.org/drawingml/2006/main">
               <a:ext uri="{FF2B5EF4-FFF2-40B4-BE49-F238E27FC236}">
-                <a16:creationId xmlns:a16="http://schemas.microsoft.com/office/drawing/2014/main" id="{7B9143C1-CDE2-4107-92C3-024D95F85969}"/>
+                <a16:creationId xmlns:a16="http://schemas.microsoft.com/office/drawing/2014/main" id="{70369A6A-BD9C-46F9-A9AA-048CF07F6C98}"/>
               </a:ext>
             </a:extLst>
           </p:cNvPr>
@@ -2768,7 +2868,7 @@
           <p:cNvPr id="15" name="">
             <a:extLst xmlns:a="http://schemas.openxmlformats.org/drawingml/2006/main">
               <a:ext uri="{FF2B5EF4-FFF2-40B4-BE49-F238E27FC236}">
-                <a16:creationId xmlns:a16="http://schemas.microsoft.com/office/drawing/2014/main" id="{385A818A-D81E-4CD9-911A-77BDAB356805}"/>
+                <a16:creationId xmlns:a16="http://schemas.microsoft.com/office/drawing/2014/main" id="{9C719FED-9D4D-4E87-8F1F-7B1778CE3BA9}"/>
               </a:ext>
             </a:extLst>
           </p:cNvPr>
@@ -2818,7 +2918,7 @@
           <p:cNvPr id="16" name="">
             <a:extLst xmlns:a="http://schemas.openxmlformats.org/drawingml/2006/main">
               <a:ext uri="{FF2B5EF4-FFF2-40B4-BE49-F238E27FC236}">
-                <a16:creationId xmlns:a16="http://schemas.microsoft.com/office/drawing/2014/main" id="{9D0DD25C-94DA-4887-AE04-ED1E9EC8051E}"/>
+                <a16:creationId xmlns:a16="http://schemas.microsoft.com/office/drawing/2014/main" id="{8DF38052-5358-4734-9A1B-4100452468BA}"/>
               </a:ext>
             </a:extLst>
           </p:cNvPr>
@@ -2868,7 +2968,7 @@
           <p:cNvPr id="17" name="">
             <a:extLst xmlns:a="http://schemas.openxmlformats.org/drawingml/2006/main">
               <a:ext uri="{FF2B5EF4-FFF2-40B4-BE49-F238E27FC236}">
-                <a16:creationId xmlns:a16="http://schemas.microsoft.com/office/drawing/2014/main" id="{49A261B7-AD18-4B71-B825-45188D44536A}"/>
+                <a16:creationId xmlns:a16="http://schemas.microsoft.com/office/drawing/2014/main" id="{B6FE5D78-2E2B-438C-904C-4957E5E1E97A}"/>
               </a:ext>
             </a:extLst>
           </p:cNvPr>
@@ -2899,7 +2999,7 @@
           <p:cNvPr id="18" name="">
             <a:extLst xmlns:a="http://schemas.openxmlformats.org/drawingml/2006/main">
               <a:ext uri="{FF2B5EF4-FFF2-40B4-BE49-F238E27FC236}">
-                <a16:creationId xmlns:a16="http://schemas.microsoft.com/office/drawing/2014/main" id="{4D052F52-018E-43BF-80C8-8AAF7CC313A3}"/>
+                <a16:creationId xmlns:a16="http://schemas.microsoft.com/office/drawing/2014/main" id="{A325F4FF-2566-4B87-B7D8-C4A9789F9479}"/>
               </a:ext>
             </a:extLst>
           </p:cNvPr>
@@ -2930,7 +3030,7 @@
           <p:cNvPr id="19" name="">
             <a:extLst xmlns:a="http://schemas.openxmlformats.org/drawingml/2006/main">
               <a:ext uri="{FF2B5EF4-FFF2-40B4-BE49-F238E27FC236}">
-                <a16:creationId xmlns:a16="http://schemas.microsoft.com/office/drawing/2014/main" id="{A95ADCE9-606C-4274-A2F4-EE4918ECC8CF}"/>
+                <a16:creationId xmlns:a16="http://schemas.microsoft.com/office/drawing/2014/main" id="{3F9EF730-04C3-4BEB-A0EB-601779952676}"/>
               </a:ext>
             </a:extLst>
           </p:cNvPr>
@@ -2980,7 +3080,7 @@
           <p:cNvPr id="20" name="">
             <a:extLst xmlns:a="http://schemas.openxmlformats.org/drawingml/2006/main">
               <a:ext uri="{FF2B5EF4-FFF2-40B4-BE49-F238E27FC236}">
-                <a16:creationId xmlns:a16="http://schemas.microsoft.com/office/drawing/2014/main" id="{C1E4BA6D-2940-431D-9CB8-0E1F44728076}"/>
+                <a16:creationId xmlns:a16="http://schemas.microsoft.com/office/drawing/2014/main" id="{64672BB8-EC31-4EAE-AB93-1F662C23AE5A}"/>
               </a:ext>
             </a:extLst>
           </p:cNvPr>
@@ -3030,7 +3130,7 @@
           <p:cNvPr id="21" name="">
             <a:extLst xmlns:a="http://schemas.openxmlformats.org/drawingml/2006/main">
               <a:ext uri="{FF2B5EF4-FFF2-40B4-BE49-F238E27FC236}">
-                <a16:creationId xmlns:a16="http://schemas.microsoft.com/office/drawing/2014/main" id="{EEDF8070-782A-492C-9B3D-F42A06D8FB9C}"/>
+                <a16:creationId xmlns:a16="http://schemas.microsoft.com/office/drawing/2014/main" id="{A15A731C-2C77-4DC5-B6FC-6DDC79CADB41}"/>
               </a:ext>
             </a:extLst>
           </p:cNvPr>
@@ -3061,7 +3161,7 @@
           <p:cNvPr id="22" name="">
             <a:extLst xmlns:a="http://schemas.openxmlformats.org/drawingml/2006/main">
               <a:ext uri="{FF2B5EF4-FFF2-40B4-BE49-F238E27FC236}">
-                <a16:creationId xmlns:a16="http://schemas.microsoft.com/office/drawing/2014/main" id="{7E23AD17-E501-4916-80DD-4E6F4F273656}"/>
+                <a16:creationId xmlns:a16="http://schemas.microsoft.com/office/drawing/2014/main" id="{5EC6FE71-B77B-43AD-971A-28D364D5AD43}"/>
               </a:ext>
             </a:extLst>
           </p:cNvPr>
@@ -3092,7 +3192,7 @@
           <p:cNvPr id="23" name="">
             <a:extLst xmlns:a="http://schemas.openxmlformats.org/drawingml/2006/main">
               <a:ext uri="{FF2B5EF4-FFF2-40B4-BE49-F238E27FC236}">
-                <a16:creationId xmlns:a16="http://schemas.microsoft.com/office/drawing/2014/main" id="{2364B885-47BC-4472-AA9D-33611333E945}"/>
+                <a16:creationId xmlns:a16="http://schemas.microsoft.com/office/drawing/2014/main" id="{68C80240-7FAE-4BD1-ADDE-C4D759212D6B}"/>
               </a:ext>
             </a:extLst>
           </p:cNvPr>
@@ -3142,7 +3242,7 @@
           <p:cNvPr id="24" name="">
             <a:extLst xmlns:a="http://schemas.openxmlformats.org/drawingml/2006/main">
               <a:ext uri="{FF2B5EF4-FFF2-40B4-BE49-F238E27FC236}">
-                <a16:creationId xmlns:a16="http://schemas.microsoft.com/office/drawing/2014/main" id="{C322BE8C-10BA-4257-9701-B3D467FCF750}"/>
+                <a16:creationId xmlns:a16="http://schemas.microsoft.com/office/drawing/2014/main" id="{BFB65336-C655-459D-8DE4-658D6947B7B7}"/>
               </a:ext>
             </a:extLst>
           </p:cNvPr>
@@ -3192,7 +3292,7 @@
           <p:cNvPr id="25" name="">
             <a:extLst xmlns:a="http://schemas.openxmlformats.org/drawingml/2006/main">
               <a:ext uri="{FF2B5EF4-FFF2-40B4-BE49-F238E27FC236}">
-                <a16:creationId xmlns:a16="http://schemas.microsoft.com/office/drawing/2014/main" id="{7CBEA475-1AF3-4B33-A85A-54652C0309D4}"/>
+                <a16:creationId xmlns:a16="http://schemas.microsoft.com/office/drawing/2014/main" id="{2202D370-86C8-4638-86DF-8D7C281F1A59}"/>
               </a:ext>
             </a:extLst>
           </p:cNvPr>
@@ -3223,7 +3323,7 @@
           <p:cNvPr id="26" name="">
             <a:extLst xmlns:a="http://schemas.openxmlformats.org/drawingml/2006/main">
               <a:ext uri="{FF2B5EF4-FFF2-40B4-BE49-F238E27FC236}">
-                <a16:creationId xmlns:a16="http://schemas.microsoft.com/office/drawing/2014/main" id="{CEDA0D46-0D4A-40BA-8CB2-C6C805F24860}"/>
+                <a16:creationId xmlns:a16="http://schemas.microsoft.com/office/drawing/2014/main" id="{02F34786-FB9B-4AE8-BBE4-7DF47E62CEEC}"/>
               </a:ext>
             </a:extLst>
           </p:cNvPr>
@@ -3254,7 +3354,7 @@
           <p:cNvPr id="27" name="">
             <a:extLst xmlns:a="http://schemas.openxmlformats.org/drawingml/2006/main">
               <a:ext uri="{FF2B5EF4-FFF2-40B4-BE49-F238E27FC236}">
-                <a16:creationId xmlns:a16="http://schemas.microsoft.com/office/drawing/2014/main" id="{6D068BB2-D2D7-4798-8B6C-6685C3F4850A}"/>
+                <a16:creationId xmlns:a16="http://schemas.microsoft.com/office/drawing/2014/main" id="{E37BFBC1-8E41-40AF-8E68-096F349B91AA}"/>
               </a:ext>
             </a:extLst>
           </p:cNvPr>
@@ -3304,7 +3404,7 @@
           <p:cNvPr id="28" name="">
             <a:extLst xmlns:a="http://schemas.openxmlformats.org/drawingml/2006/main">
               <a:ext uri="{FF2B5EF4-FFF2-40B4-BE49-F238E27FC236}">
-                <a16:creationId xmlns:a16="http://schemas.microsoft.com/office/drawing/2014/main" id="{96631DF7-70CB-41AB-BA7C-A2D0C1A229AA}"/>
+                <a16:creationId xmlns:a16="http://schemas.microsoft.com/office/drawing/2014/main" id="{25D959DC-AC7F-4CFB-AC6C-F826B46D4371}"/>
               </a:ext>
             </a:extLst>
           </p:cNvPr>
@@ -3354,7 +3454,7 @@
           <p:cNvPr id="29" name="">
             <a:extLst xmlns:a="http://schemas.openxmlformats.org/drawingml/2006/main">
               <a:ext uri="{FF2B5EF4-FFF2-40B4-BE49-F238E27FC236}">
-                <a16:creationId xmlns:a16="http://schemas.microsoft.com/office/drawing/2014/main" id="{05FC2112-453B-4431-AA54-60DF147E5F18}"/>
+                <a16:creationId xmlns:a16="http://schemas.microsoft.com/office/drawing/2014/main" id="{BC064D49-70F1-46A7-8B14-5ABF251BA5BF}"/>
               </a:ext>
             </a:extLst>
           </p:cNvPr>
@@ -3385,7 +3485,7 @@
           <p:cNvPr id="30" name="">
             <a:extLst xmlns:a="http://schemas.openxmlformats.org/drawingml/2006/main">
               <a:ext uri="{FF2B5EF4-FFF2-40B4-BE49-F238E27FC236}">
-                <a16:creationId xmlns:a16="http://schemas.microsoft.com/office/drawing/2014/main" id="{552931F9-F4B5-4C98-BC2F-ABEDB9B519BA}"/>
+                <a16:creationId xmlns:a16="http://schemas.microsoft.com/office/drawing/2014/main" id="{C5D62C77-8251-4F56-8F99-3F6EA76FA418}"/>
               </a:ext>
             </a:extLst>
           </p:cNvPr>
@@ -3416,7 +3516,7 @@
           <p:cNvPr id="31" name="">
             <a:extLst xmlns:a="http://schemas.openxmlformats.org/drawingml/2006/main">
               <a:ext uri="{FF2B5EF4-FFF2-40B4-BE49-F238E27FC236}">
-                <a16:creationId xmlns:a16="http://schemas.microsoft.com/office/drawing/2014/main" id="{5346BF16-13BB-4D3E-B516-1C448CDC8293}"/>
+                <a16:creationId xmlns:a16="http://schemas.microsoft.com/office/drawing/2014/main" id="{9D10685D-584A-4A61-92B5-8F9F1BDF0D49}"/>
               </a:ext>
             </a:extLst>
           </p:cNvPr>
@@ -3466,7 +3566,7 @@
           <p:cNvPr id="32" name="">
             <a:extLst xmlns:a="http://schemas.openxmlformats.org/drawingml/2006/main">
               <a:ext uri="{FF2B5EF4-FFF2-40B4-BE49-F238E27FC236}">
-                <a16:creationId xmlns:a16="http://schemas.microsoft.com/office/drawing/2014/main" id="{F821AF47-F4BF-43BD-B95B-08717BA54F77}"/>
+                <a16:creationId xmlns:a16="http://schemas.microsoft.com/office/drawing/2014/main" id="{CD6483EF-C8B8-4E81-BFAB-593202A8C5D3}"/>
               </a:ext>
             </a:extLst>
           </p:cNvPr>
@@ -3516,7 +3616,7 @@
           <p:cNvPr id="33" name="">
             <a:extLst xmlns:a="http://schemas.openxmlformats.org/drawingml/2006/main">
               <a:ext uri="{FF2B5EF4-FFF2-40B4-BE49-F238E27FC236}">
-                <a16:creationId xmlns:a16="http://schemas.microsoft.com/office/drawing/2014/main" id="{EF9830CE-32DA-4950-9BB3-B0CCBDE29697}"/>
+                <a16:creationId xmlns:a16="http://schemas.microsoft.com/office/drawing/2014/main" id="{615F3D17-532F-4304-A29D-1DF6B3D7D213}"/>
               </a:ext>
             </a:extLst>
           </p:cNvPr>
@@ -3547,7 +3647,7 @@
           <p:cNvPr id="34" name="">
             <a:extLst xmlns:a="http://schemas.openxmlformats.org/drawingml/2006/main">
               <a:ext uri="{FF2B5EF4-FFF2-40B4-BE49-F238E27FC236}">
-                <a16:creationId xmlns:a16="http://schemas.microsoft.com/office/drawing/2014/main" id="{F0C1581F-4AFB-4181-8889-73930C1C3C31}"/>
+                <a16:creationId xmlns:a16="http://schemas.microsoft.com/office/drawing/2014/main" id="{E40E10D0-8A79-4EBA-8EBC-60C917CE45BF}"/>
               </a:ext>
             </a:extLst>
           </p:cNvPr>
@@ -3578,7 +3678,7 @@
           <p:cNvPr id="35" name="">
             <a:extLst xmlns:a="http://schemas.openxmlformats.org/drawingml/2006/main">
               <a:ext uri="{FF2B5EF4-FFF2-40B4-BE49-F238E27FC236}">
-                <a16:creationId xmlns:a16="http://schemas.microsoft.com/office/drawing/2014/main" id="{F7A62BA8-0EB4-4881-AD55-A842CF52BFA4}"/>
+                <a16:creationId xmlns:a16="http://schemas.microsoft.com/office/drawing/2014/main" id="{D52D7F91-310C-45C8-8967-3700EF1C1F67}"/>
               </a:ext>
             </a:extLst>
           </p:cNvPr>
@@ -3628,7 +3728,7 @@
           <p:cNvPr id="36" name="">
             <a:extLst xmlns:a="http://schemas.openxmlformats.org/drawingml/2006/main">
               <a:ext uri="{FF2B5EF4-FFF2-40B4-BE49-F238E27FC236}">
-                <a16:creationId xmlns:a16="http://schemas.microsoft.com/office/drawing/2014/main" id="{5B4F49A3-8D26-4DE5-8615-A193C5AEFAE1}"/>
+                <a16:creationId xmlns:a16="http://schemas.microsoft.com/office/drawing/2014/main" id="{402FB760-0B79-4B9D-8905-AD058EC3567D}"/>
               </a:ext>
             </a:extLst>
           </p:cNvPr>
@@ -3678,7 +3778,7 @@
           <p:cNvPr id="37" name="">
             <a:extLst xmlns:a="http://schemas.openxmlformats.org/drawingml/2006/main">
               <a:ext uri="{FF2B5EF4-FFF2-40B4-BE49-F238E27FC236}">
-                <a16:creationId xmlns:a16="http://schemas.microsoft.com/office/drawing/2014/main" id="{BD648747-FDD7-45EA-B092-45637325B1C3}"/>
+                <a16:creationId xmlns:a16="http://schemas.microsoft.com/office/drawing/2014/main" id="{1475126C-9332-441D-A081-CB7A4D18FD8B}"/>
               </a:ext>
             </a:extLst>
           </p:cNvPr>
@@ -3709,7 +3809,7 @@
           <p:cNvPr id="38" name="">
             <a:extLst xmlns:a="http://schemas.openxmlformats.org/drawingml/2006/main">
               <a:ext uri="{FF2B5EF4-FFF2-40B4-BE49-F238E27FC236}">
-                <a16:creationId xmlns:a16="http://schemas.microsoft.com/office/drawing/2014/main" id="{12FD0407-72B2-4348-BF78-A87BF5D3686A}"/>
+                <a16:creationId xmlns:a16="http://schemas.microsoft.com/office/drawing/2014/main" id="{848FD1B4-F7E5-4D4D-8E4B-726010444CC6}"/>
               </a:ext>
             </a:extLst>
           </p:cNvPr>
@@ -3740,7 +3840,7 @@
           <p:cNvPr id="39" name="">
             <a:extLst xmlns:a="http://schemas.openxmlformats.org/drawingml/2006/main">
               <a:ext uri="{FF2B5EF4-FFF2-40B4-BE49-F238E27FC236}">
-                <a16:creationId xmlns:a16="http://schemas.microsoft.com/office/drawing/2014/main" id="{11ADEBBE-BEB9-497A-A9A0-4A57BC908536}"/>
+                <a16:creationId xmlns:a16="http://schemas.microsoft.com/office/drawing/2014/main" id="{3E0F74A6-0EDA-4C59-BF07-F1CD25330239}"/>
               </a:ext>
             </a:extLst>
           </p:cNvPr>
@@ -3790,7 +3890,7 @@
           <p:cNvPr id="40" name="">
             <a:extLst xmlns:a="http://schemas.openxmlformats.org/drawingml/2006/main">
               <a:ext uri="{FF2B5EF4-FFF2-40B4-BE49-F238E27FC236}">
-                <a16:creationId xmlns:a16="http://schemas.microsoft.com/office/drawing/2014/main" id="{5D2D8657-9414-48C0-8BC2-2D13F80EC911}"/>
+                <a16:creationId xmlns:a16="http://schemas.microsoft.com/office/drawing/2014/main" id="{7A3325E7-6678-4180-A678-16FAE128934E}"/>
               </a:ext>
             </a:extLst>
           </p:cNvPr>
@@ -3840,7 +3940,7 @@
           <p:cNvPr id="41" name="">
             <a:extLst xmlns:a="http://schemas.openxmlformats.org/drawingml/2006/main">
               <a:ext uri="{FF2B5EF4-FFF2-40B4-BE49-F238E27FC236}">
-                <a16:creationId xmlns:a16="http://schemas.microsoft.com/office/drawing/2014/main" id="{08DC6C87-11F3-4FB4-B350-E6D4C219E7B2}"/>
+                <a16:creationId xmlns:a16="http://schemas.microsoft.com/office/drawing/2014/main" id="{3ADA9439-D467-4688-9096-D2FF12FB4E58}"/>
               </a:ext>
             </a:extLst>
           </p:cNvPr>
@@ -3871,7 +3971,7 @@
           <p:cNvPr id="42" name="">
             <a:extLst xmlns:a="http://schemas.openxmlformats.org/drawingml/2006/main">
               <a:ext uri="{FF2B5EF4-FFF2-40B4-BE49-F238E27FC236}">
-                <a16:creationId xmlns:a16="http://schemas.microsoft.com/office/drawing/2014/main" id="{6203BFF6-6F9D-440D-80BA-9B8DE9EE3707}"/>
+                <a16:creationId xmlns:a16="http://schemas.microsoft.com/office/drawing/2014/main" id="{9DB98D87-E19A-4518-8679-E06C3B3401BE}"/>
               </a:ext>
             </a:extLst>
           </p:cNvPr>
@@ -3902,7 +4002,7 @@
           <p:cNvPr id="43" name="">
             <a:extLst xmlns:a="http://schemas.openxmlformats.org/drawingml/2006/main">
               <a:ext uri="{FF2B5EF4-FFF2-40B4-BE49-F238E27FC236}">
-                <a16:creationId xmlns:a16="http://schemas.microsoft.com/office/drawing/2014/main" id="{53B81D65-84CA-456B-8856-984FB5BBB520}"/>
+                <a16:creationId xmlns:a16="http://schemas.microsoft.com/office/drawing/2014/main" id="{5DD57BFD-784A-48B0-A4AE-632DC752837E}"/>
               </a:ext>
             </a:extLst>
           </p:cNvPr>
@@ -3952,7 +4052,7 @@
           <p:cNvPr id="44" name="">
             <a:extLst xmlns:a="http://schemas.openxmlformats.org/drawingml/2006/main">
               <a:ext uri="{FF2B5EF4-FFF2-40B4-BE49-F238E27FC236}">
-                <a16:creationId xmlns:a16="http://schemas.microsoft.com/office/drawing/2014/main" id="{86CA8BB6-57AD-42F1-B43C-E6539D4FE452}"/>
+                <a16:creationId xmlns:a16="http://schemas.microsoft.com/office/drawing/2014/main" id="{11AD2F9B-BA19-4949-B5BD-BD684FF7E6E0}"/>
               </a:ext>
             </a:extLst>
           </p:cNvPr>
@@ -4002,7 +4102,7 @@
           <p:cNvPr id="45" name="">
             <a:extLst xmlns:a="http://schemas.openxmlformats.org/drawingml/2006/main">
               <a:ext uri="{FF2B5EF4-FFF2-40B4-BE49-F238E27FC236}">
-                <a16:creationId xmlns:a16="http://schemas.microsoft.com/office/drawing/2014/main" id="{5108DD89-A548-4836-8F09-1B404F05DC13}"/>
+                <a16:creationId xmlns:a16="http://schemas.microsoft.com/office/drawing/2014/main" id="{8D06C8E0-4D79-4A39-8852-481439FCE7AD}"/>
               </a:ext>
             </a:extLst>
           </p:cNvPr>
@@ -4033,7 +4133,7 @@
           <p:cNvPr id="46" name="">
             <a:extLst xmlns:a="http://schemas.openxmlformats.org/drawingml/2006/main">
               <a:ext uri="{FF2B5EF4-FFF2-40B4-BE49-F238E27FC236}">
-                <a16:creationId xmlns:a16="http://schemas.microsoft.com/office/drawing/2014/main" id="{CFD18647-591E-4FAC-B923-6BD7E969CF94}"/>
+                <a16:creationId xmlns:a16="http://schemas.microsoft.com/office/drawing/2014/main" id="{368F90D1-7A8E-4F5A-8741-B3D437E1BD5A}"/>
               </a:ext>
             </a:extLst>
           </p:cNvPr>
@@ -4083,7 +4183,7 @@
           <p:cNvPr id="47" name="">
             <a:extLst xmlns:a="http://schemas.openxmlformats.org/drawingml/2006/main">
               <a:ext uri="{FF2B5EF4-FFF2-40B4-BE49-F238E27FC236}">
-                <a16:creationId xmlns:a16="http://schemas.microsoft.com/office/drawing/2014/main" id="{1FBD5074-9CF7-431F-BA5F-A3F204C6754C}"/>
+                <a16:creationId xmlns:a16="http://schemas.microsoft.com/office/drawing/2014/main" id="{18F42A62-F2B1-4688-A592-30D06984D8FA}"/>
               </a:ext>
             </a:extLst>
           </p:cNvPr>
@@ -4131,7 +4231,7 @@
     </p:spTree>
     <p:extLst>
       <p:ext uri="{BB962C8B-B14F-4D97-AF65-F5344CB8AC3E}">
-        <p14:creationId xmlns:p14="http://schemas.microsoft.com/office/powerpoint/2010/main" val="1918342002"/>
+        <p14:creationId xmlns:p14="http://schemas.microsoft.com/office/powerpoint/2010/main" val="1469361885"/>
       </p:ext>
     </p:extLst>
   </p:cSld>
@@ -4162,7 +4262,7 @@
           <p:cNvPr id="20" name="">
             <a:extLst xmlns:a="http://schemas.openxmlformats.org/drawingml/2006/main">
               <a:ext uri="{FF2B5EF4-FFF2-40B4-BE49-F238E27FC236}">
-                <a16:creationId xmlns:a16="http://schemas.microsoft.com/office/drawing/2014/main" id="{2ACC8EBF-0000-4166-A228-A11C755A825C}"/>
+                <a16:creationId xmlns:a16="http://schemas.microsoft.com/office/drawing/2014/main" id="{BC3938A9-3B65-4F00-9E10-64B503C4E5A4}"/>
               </a:ext>
             </a:extLst>
           </p:cNvPr>
@@ -4212,7 +4312,7 @@
           <p:cNvPr id="2" name="">
             <a:extLst xmlns:a="http://schemas.openxmlformats.org/drawingml/2006/main">
               <a:ext uri="{FF2B5EF4-FFF2-40B4-BE49-F238E27FC236}">
-                <a16:creationId xmlns:a16="http://schemas.microsoft.com/office/drawing/2014/main" id="{16DA8A7F-BDF9-4072-972B-B85D802C2D69}"/>
+                <a16:creationId xmlns:a16="http://schemas.microsoft.com/office/drawing/2014/main" id="{99FF16C8-D17F-4182-92CD-D39B617F13E2}"/>
               </a:ext>
             </a:extLst>
           </p:cNvPr>
@@ -4262,7 +4362,7 @@
           <p:cNvPr id="3" name="">
             <a:extLst xmlns:a="http://schemas.openxmlformats.org/drawingml/2006/main">
               <a:ext uri="{FF2B5EF4-FFF2-40B4-BE49-F238E27FC236}">
-                <a16:creationId xmlns:a16="http://schemas.microsoft.com/office/drawing/2014/main" id="{EEC1F291-F4F8-476B-BB3F-A511AE980127}"/>
+                <a16:creationId xmlns:a16="http://schemas.microsoft.com/office/drawing/2014/main" id="{171500A0-FACE-4833-BCF7-FD663733FAC1}"/>
               </a:ext>
             </a:extLst>
           </p:cNvPr>
@@ -4293,7 +4393,7 @@
           <p:cNvPr id="4" name="">
             <a:extLst xmlns:a="http://schemas.openxmlformats.org/drawingml/2006/main">
               <a:ext uri="{FF2B5EF4-FFF2-40B4-BE49-F238E27FC236}">
-                <a16:creationId xmlns:a16="http://schemas.microsoft.com/office/drawing/2014/main" id="{7101EA93-A5F2-4EC6-8663-084771512466}"/>
+                <a16:creationId xmlns:a16="http://schemas.microsoft.com/office/drawing/2014/main" id="{FB8E4853-CC46-45D9-B280-4C40A125E3DB}"/>
               </a:ext>
             </a:extLst>
           </p:cNvPr>
@@ -4343,7 +4443,7 @@
           <p:cNvPr id="5" name="">
             <a:extLst xmlns:a="http://schemas.openxmlformats.org/drawingml/2006/main">
               <a:ext uri="{FF2B5EF4-FFF2-40B4-BE49-F238E27FC236}">
-                <a16:creationId xmlns:a16="http://schemas.microsoft.com/office/drawing/2014/main" id="{5FA6A6BA-4A2F-4F03-B7E2-3BDB17E4D8AF}"/>
+                <a16:creationId xmlns:a16="http://schemas.microsoft.com/office/drawing/2014/main" id="{86C51B6B-4218-427A-8821-8211B8BEF3BC}"/>
               </a:ext>
             </a:extLst>
           </p:cNvPr>
@@ -4374,7 +4474,7 @@
           <p:cNvPr id="6" name="">
             <a:extLst xmlns:a="http://schemas.openxmlformats.org/drawingml/2006/main">
               <a:ext uri="{FF2B5EF4-FFF2-40B4-BE49-F238E27FC236}">
-                <a16:creationId xmlns:a16="http://schemas.microsoft.com/office/drawing/2014/main" id="{D6EDF6E9-1084-45F8-A0D7-A3D44DE16A26}"/>
+                <a16:creationId xmlns:a16="http://schemas.microsoft.com/office/drawing/2014/main" id="{08E1C05A-C16F-4D11-9584-3940A4387F8D}"/>
               </a:ext>
             </a:extLst>
           </p:cNvPr>
@@ -4441,7 +4541,7 @@
           <p:cNvPr id="7" name="">
             <a:extLst xmlns:a="http://schemas.openxmlformats.org/drawingml/2006/main">
               <a:ext uri="{FF2B5EF4-FFF2-40B4-BE49-F238E27FC236}">
-                <a16:creationId xmlns:a16="http://schemas.microsoft.com/office/drawing/2014/main" id="{89234A9F-B4E8-477B-A380-103361ACF093}"/>
+                <a16:creationId xmlns:a16="http://schemas.microsoft.com/office/drawing/2014/main" id="{3D43B0FB-0DAC-49B8-A403-AC8FCC5285E2}"/>
               </a:ext>
             </a:extLst>
           </p:cNvPr>
@@ -4491,7 +4591,7 @@
           <p:cNvPr id="8" name="">
             <a:extLst xmlns:a="http://schemas.openxmlformats.org/drawingml/2006/main">
               <a:ext uri="{FF2B5EF4-FFF2-40B4-BE49-F238E27FC236}">
-                <a16:creationId xmlns:a16="http://schemas.microsoft.com/office/drawing/2014/main" id="{01EBC1D0-22A6-49E1-8A09-DD470C4AF025}"/>
+                <a16:creationId xmlns:a16="http://schemas.microsoft.com/office/drawing/2014/main" id="{9354264A-6379-483F-8EC7-801628191249}"/>
               </a:ext>
             </a:extLst>
           </p:cNvPr>
@@ -4541,7 +4641,7 @@
           <p:cNvPr id="9" name="">
             <a:extLst xmlns:a="http://schemas.openxmlformats.org/drawingml/2006/main">
               <a:ext uri="{FF2B5EF4-FFF2-40B4-BE49-F238E27FC236}">
-                <a16:creationId xmlns:a16="http://schemas.microsoft.com/office/drawing/2014/main" id="{5B24ADDC-412E-43E1-9E18-95139AC5594B}"/>
+                <a16:creationId xmlns:a16="http://schemas.microsoft.com/office/drawing/2014/main" id="{85EA1D9F-6BD7-4BA4-B3BB-6A8D5EB91AF7}"/>
               </a:ext>
             </a:extLst>
           </p:cNvPr>
@@ -4572,7 +4672,7 @@
           <p:cNvPr id="10" name="">
             <a:extLst xmlns:a="http://schemas.openxmlformats.org/drawingml/2006/main">
               <a:ext uri="{FF2B5EF4-FFF2-40B4-BE49-F238E27FC236}">
-                <a16:creationId xmlns:a16="http://schemas.microsoft.com/office/drawing/2014/main" id="{94F43B17-ECD6-4725-8F6B-C7F1E4879334}"/>
+                <a16:creationId xmlns:a16="http://schemas.microsoft.com/office/drawing/2014/main" id="{09E0D6D6-1A6B-49A6-90FC-9A4CFD72E4D7}"/>
               </a:ext>
             </a:extLst>
           </p:cNvPr>
@@ -4639,7 +4739,7 @@
           <p:cNvPr id="11" name="">
             <a:extLst xmlns:a="http://schemas.openxmlformats.org/drawingml/2006/main">
               <a:ext uri="{FF2B5EF4-FFF2-40B4-BE49-F238E27FC236}">
-                <a16:creationId xmlns:a16="http://schemas.microsoft.com/office/drawing/2014/main" id="{E0DB00B4-3957-4E6A-B1D7-3640C79772A9}"/>
+                <a16:creationId xmlns:a16="http://schemas.microsoft.com/office/drawing/2014/main" id="{9F5E83B7-60FF-4057-81D4-20A2E466290A}"/>
               </a:ext>
             </a:extLst>
           </p:cNvPr>
@@ -4689,7 +4789,7 @@
           <p:cNvPr id="12" name="">
             <a:extLst xmlns:a="http://schemas.openxmlformats.org/drawingml/2006/main">
               <a:ext uri="{FF2B5EF4-FFF2-40B4-BE49-F238E27FC236}">
-                <a16:creationId xmlns:a16="http://schemas.microsoft.com/office/drawing/2014/main" id="{5849B24D-1A3E-49BC-9806-DA748BFE2579}"/>
+                <a16:creationId xmlns:a16="http://schemas.microsoft.com/office/drawing/2014/main" id="{AA562FE2-97CB-4F3D-9386-289A094274DF}"/>
               </a:ext>
             </a:extLst>
           </p:cNvPr>
@@ -4739,7 +4839,7 @@
           <p:cNvPr id="13" name="">
             <a:extLst xmlns:a="http://schemas.openxmlformats.org/drawingml/2006/main">
               <a:ext uri="{FF2B5EF4-FFF2-40B4-BE49-F238E27FC236}">
-                <a16:creationId xmlns:a16="http://schemas.microsoft.com/office/drawing/2014/main" id="{B4093BFA-E112-45E9-AA16-3C1C3568C48D}"/>
+                <a16:creationId xmlns:a16="http://schemas.microsoft.com/office/drawing/2014/main" id="{BF05458E-FCA9-41CD-95D7-C8C86220DF86}"/>
               </a:ext>
             </a:extLst>
           </p:cNvPr>
@@ -4770,7 +4870,7 @@
           <p:cNvPr id="14" name="">
             <a:extLst xmlns:a="http://schemas.openxmlformats.org/drawingml/2006/main">
               <a:ext uri="{FF2B5EF4-FFF2-40B4-BE49-F238E27FC236}">
-                <a16:creationId xmlns:a16="http://schemas.microsoft.com/office/drawing/2014/main" id="{26FF9C7D-0C53-41DD-85CD-4A91334D0492}"/>
+                <a16:creationId xmlns:a16="http://schemas.microsoft.com/office/drawing/2014/main" id="{653B5899-480A-4797-94F0-98A84EED8E83}"/>
               </a:ext>
             </a:extLst>
           </p:cNvPr>
@@ -4837,7 +4937,7 @@
           <p:cNvPr id="15" name="">
             <a:extLst xmlns:a="http://schemas.openxmlformats.org/drawingml/2006/main">
               <a:ext uri="{FF2B5EF4-FFF2-40B4-BE49-F238E27FC236}">
-                <a16:creationId xmlns:a16="http://schemas.microsoft.com/office/drawing/2014/main" id="{4D18427B-B27B-4D93-B718-144B61F20518}"/>
+                <a16:creationId xmlns:a16="http://schemas.microsoft.com/office/drawing/2014/main" id="{3E726A70-08D8-4F68-8A41-1024F00ADCDF}"/>
               </a:ext>
             </a:extLst>
           </p:cNvPr>
@@ -4887,7 +4987,7 @@
           <p:cNvPr id="16" name="">
             <a:extLst xmlns:a="http://schemas.openxmlformats.org/drawingml/2006/main">
               <a:ext uri="{FF2B5EF4-FFF2-40B4-BE49-F238E27FC236}">
-                <a16:creationId xmlns:a16="http://schemas.microsoft.com/office/drawing/2014/main" id="{55275693-AD57-486F-AA0E-1EB53D273AB5}"/>
+                <a16:creationId xmlns:a16="http://schemas.microsoft.com/office/drawing/2014/main" id="{70D93903-8335-425A-901D-C9D883062D92}"/>
               </a:ext>
             </a:extLst>
           </p:cNvPr>
@@ -4918,7 +5018,7 @@
           <p:cNvPr id="17" name="">
             <a:extLst xmlns:a="http://schemas.openxmlformats.org/drawingml/2006/main">
               <a:ext uri="{FF2B5EF4-FFF2-40B4-BE49-F238E27FC236}">
-                <a16:creationId xmlns:a16="http://schemas.microsoft.com/office/drawing/2014/main" id="{5B01C75B-F918-47AF-8C61-B3748858470A}"/>
+                <a16:creationId xmlns:a16="http://schemas.microsoft.com/office/drawing/2014/main" id="{6C455249-8433-41BC-A845-65345EC514C8}"/>
               </a:ext>
             </a:extLst>
           </p:cNvPr>
@@ -4968,7 +5068,7 @@
           <p:cNvPr id="18" name="">
             <a:extLst xmlns:a="http://schemas.openxmlformats.org/drawingml/2006/main">
               <a:ext uri="{FF2B5EF4-FFF2-40B4-BE49-F238E27FC236}">
-                <a16:creationId xmlns:a16="http://schemas.microsoft.com/office/drawing/2014/main" id="{36EE576D-8965-4980-8CAB-0AA9EAB617DC}"/>
+                <a16:creationId xmlns:a16="http://schemas.microsoft.com/office/drawing/2014/main" id="{7D6422D5-6F7B-46F0-ABF3-3681969634C8}"/>
               </a:ext>
             </a:extLst>
           </p:cNvPr>
@@ -5018,7 +5118,7 @@
           <p:cNvPr id="19" name="">
             <a:extLst xmlns:a="http://schemas.openxmlformats.org/drawingml/2006/main">
               <a:ext uri="{FF2B5EF4-FFF2-40B4-BE49-F238E27FC236}">
-                <a16:creationId xmlns:a16="http://schemas.microsoft.com/office/drawing/2014/main" id="{28A0ACD5-FC2E-4192-9DC0-7D047674A316}"/>
+                <a16:creationId xmlns:a16="http://schemas.microsoft.com/office/drawing/2014/main" id="{7BAB0933-3E47-4634-AC12-7C692F9EADE9}"/>
               </a:ext>
             </a:extLst>
           </p:cNvPr>
@@ -5066,7 +5166,7 @@
     </p:spTree>
     <p:extLst>
       <p:ext uri="{BB962C8B-B14F-4D97-AF65-F5344CB8AC3E}">
-        <p14:creationId xmlns:p14="http://schemas.microsoft.com/office/powerpoint/2010/main" val="1324841637"/>
+        <p14:creationId xmlns:p14="http://schemas.microsoft.com/office/powerpoint/2010/main" val="1425350070"/>
       </p:ext>
     </p:extLst>
   </p:cSld>
@@ -5097,7 +5197,7 @@
           <p:cNvPr id="18" name="">
             <a:extLst xmlns:a="http://schemas.openxmlformats.org/drawingml/2006/main">
               <a:ext uri="{FF2B5EF4-FFF2-40B4-BE49-F238E27FC236}">
-                <a16:creationId xmlns:a16="http://schemas.microsoft.com/office/drawing/2014/main" id="{5EA8D61B-7BFD-4F69-A5E9-901687E47E51}"/>
+                <a16:creationId xmlns:a16="http://schemas.microsoft.com/office/drawing/2014/main" id="{050A5B96-A925-4E2A-91E2-2EA3C1587D51}"/>
               </a:ext>
             </a:extLst>
           </p:cNvPr>
@@ -5147,7 +5247,7 @@
           <p:cNvPr id="2" name="">
             <a:extLst xmlns:a="http://schemas.openxmlformats.org/drawingml/2006/main">
               <a:ext uri="{FF2B5EF4-FFF2-40B4-BE49-F238E27FC236}">
-                <a16:creationId xmlns:a16="http://schemas.microsoft.com/office/drawing/2014/main" id="{E3209D8B-2E90-4319-9010-963D3E431881}"/>
+                <a16:creationId xmlns:a16="http://schemas.microsoft.com/office/drawing/2014/main" id="{205C634B-CC68-43EF-BF55-3253507D26B3}"/>
               </a:ext>
             </a:extLst>
           </p:cNvPr>
@@ -5197,7 +5297,7 @@
           <p:cNvPr id="3" name="">
             <a:extLst xmlns:a="http://schemas.openxmlformats.org/drawingml/2006/main">
               <a:ext uri="{FF2B5EF4-FFF2-40B4-BE49-F238E27FC236}">
-                <a16:creationId xmlns:a16="http://schemas.microsoft.com/office/drawing/2014/main" id="{1D93C95B-84B3-4B5F-9970-DCE1A6EE480E}"/>
+                <a16:creationId xmlns:a16="http://schemas.microsoft.com/office/drawing/2014/main" id="{D46552E8-44FE-4E2A-BCC7-A3E53EC9F905}"/>
               </a:ext>
             </a:extLst>
           </p:cNvPr>
@@ -5228,7 +5328,7 @@
           <p:cNvPr id="4" name="">
             <a:extLst xmlns:a="http://schemas.openxmlformats.org/drawingml/2006/main">
               <a:ext uri="{FF2B5EF4-FFF2-40B4-BE49-F238E27FC236}">
-                <a16:creationId xmlns:a16="http://schemas.microsoft.com/office/drawing/2014/main" id="{6A664B08-5BD5-45C9-B5F7-8737D6E61CF7}"/>
+                <a16:creationId xmlns:a16="http://schemas.microsoft.com/office/drawing/2014/main" id="{85D692C9-6699-493E-9D6B-42FC6EF6FAB4}"/>
               </a:ext>
             </a:extLst>
           </p:cNvPr>
@@ -5259,7 +5359,7 @@
           <p:cNvPr id="5" name="">
             <a:extLst xmlns:a="http://schemas.openxmlformats.org/drawingml/2006/main">
               <a:ext uri="{FF2B5EF4-FFF2-40B4-BE49-F238E27FC236}">
-                <a16:creationId xmlns:a16="http://schemas.microsoft.com/office/drawing/2014/main" id="{988A7F4E-FC20-4908-A4B7-168A7D1F57DA}"/>
+                <a16:creationId xmlns:a16="http://schemas.microsoft.com/office/drawing/2014/main" id="{CC23ACEB-8093-4518-9241-3E32BDF2FFBB}"/>
               </a:ext>
             </a:extLst>
           </p:cNvPr>
@@ -5290,7 +5390,7 @@
           <p:cNvPr id="6" name="">
             <a:extLst xmlns:a="http://schemas.openxmlformats.org/drawingml/2006/main">
               <a:ext uri="{FF2B5EF4-FFF2-40B4-BE49-F238E27FC236}">
-                <a16:creationId xmlns:a16="http://schemas.microsoft.com/office/drawing/2014/main" id="{17C9093A-5867-40D8-BDFA-BD21FE6376DF}"/>
+                <a16:creationId xmlns:a16="http://schemas.microsoft.com/office/drawing/2014/main" id="{AE7A0419-67BC-411E-BE8C-06FE0D1C5A4D}"/>
               </a:ext>
             </a:extLst>
           </p:cNvPr>
@@ -5340,7 +5440,7 @@
           <p:cNvPr id="7" name="">
             <a:extLst xmlns:a="http://schemas.openxmlformats.org/drawingml/2006/main">
               <a:ext uri="{FF2B5EF4-FFF2-40B4-BE49-F238E27FC236}">
-                <a16:creationId xmlns:a16="http://schemas.microsoft.com/office/drawing/2014/main" id="{4D7C4F94-6FA0-4EC1-A84A-021A374BFFBC}"/>
+                <a16:creationId xmlns:a16="http://schemas.microsoft.com/office/drawing/2014/main" id="{E59B48B4-E48B-4ECC-B12E-64436B4A4C31}"/>
               </a:ext>
             </a:extLst>
           </p:cNvPr>
@@ -5390,7 +5490,7 @@
           <p:cNvPr id="8" name="">
             <a:extLst xmlns:a="http://schemas.openxmlformats.org/drawingml/2006/main">
               <a:ext uri="{FF2B5EF4-FFF2-40B4-BE49-F238E27FC236}">
-                <a16:creationId xmlns:a16="http://schemas.microsoft.com/office/drawing/2014/main" id="{79AB8CEE-3E31-4456-BD30-99744DD90CB9}"/>
+                <a16:creationId xmlns:a16="http://schemas.microsoft.com/office/drawing/2014/main" id="{9CDD86B7-BDBB-4BC1-B7F5-721BCCA9AF7C}"/>
               </a:ext>
             </a:extLst>
           </p:cNvPr>
@@ -5457,7 +5557,7 @@
           <p:cNvPr id="9" name="">
             <a:extLst xmlns:a="http://schemas.openxmlformats.org/drawingml/2006/main">
               <a:ext uri="{FF2B5EF4-FFF2-40B4-BE49-F238E27FC236}">
-                <a16:creationId xmlns:a16="http://schemas.microsoft.com/office/drawing/2014/main" id="{BA579DE7-D3BA-4D30-B402-844FB204DD25}"/>
+                <a16:creationId xmlns:a16="http://schemas.microsoft.com/office/drawing/2014/main" id="{BDB28B2E-6EDF-4C5F-A2F4-A5EDA53FD716}"/>
               </a:ext>
             </a:extLst>
           </p:cNvPr>
@@ -5507,7 +5607,7 @@
           <p:cNvPr id="10" name="">
             <a:extLst xmlns:a="http://schemas.openxmlformats.org/drawingml/2006/main">
               <a:ext uri="{FF2B5EF4-FFF2-40B4-BE49-F238E27FC236}">
-                <a16:creationId xmlns:a16="http://schemas.microsoft.com/office/drawing/2014/main" id="{94E6B8BD-0AD2-4E4A-BB93-9042CCB835AA}"/>
+                <a16:creationId xmlns:a16="http://schemas.microsoft.com/office/drawing/2014/main" id="{DFEB03BA-4BD2-485C-AB72-2000074867F3}"/>
               </a:ext>
             </a:extLst>
           </p:cNvPr>
@@ -5557,7 +5657,7 @@
           <p:cNvPr id="11" name="">
             <a:extLst xmlns:a="http://schemas.openxmlformats.org/drawingml/2006/main">
               <a:ext uri="{FF2B5EF4-FFF2-40B4-BE49-F238E27FC236}">
-                <a16:creationId xmlns:a16="http://schemas.microsoft.com/office/drawing/2014/main" id="{C40CD32D-98F5-44F9-B26C-0573EC3B374E}"/>
+                <a16:creationId xmlns:a16="http://schemas.microsoft.com/office/drawing/2014/main" id="{258D3514-3DF5-490C-A96C-DB44B571C9C6}"/>
               </a:ext>
             </a:extLst>
           </p:cNvPr>
@@ -5607,7 +5707,7 @@
           <p:cNvPr id="12" name="">
             <a:extLst xmlns:a="http://schemas.openxmlformats.org/drawingml/2006/main">
               <a:ext uri="{FF2B5EF4-FFF2-40B4-BE49-F238E27FC236}">
-                <a16:creationId xmlns:a16="http://schemas.microsoft.com/office/drawing/2014/main" id="{6E253601-CFDB-4F16-87CA-059F859A1131}"/>
+                <a16:creationId xmlns:a16="http://schemas.microsoft.com/office/drawing/2014/main" id="{5D5F98D2-CE2A-47ED-B242-591D7EB2A177}"/>
               </a:ext>
             </a:extLst>
           </p:cNvPr>
@@ -5657,7 +5757,7 @@
           <p:cNvPr id="13" name="">
             <a:extLst xmlns:a="http://schemas.openxmlformats.org/drawingml/2006/main">
               <a:ext uri="{FF2B5EF4-FFF2-40B4-BE49-F238E27FC236}">
-                <a16:creationId xmlns:a16="http://schemas.microsoft.com/office/drawing/2014/main" id="{D340666F-9283-4C4F-A5C1-4ABBA1FDC5FE}"/>
+                <a16:creationId xmlns:a16="http://schemas.microsoft.com/office/drawing/2014/main" id="{B589D893-6767-41D5-A90D-4038D5C69D62}"/>
               </a:ext>
             </a:extLst>
           </p:cNvPr>
@@ -5707,7 +5807,7 @@
           <p:cNvPr id="14" name="">
             <a:extLst xmlns:a="http://schemas.openxmlformats.org/drawingml/2006/main">
               <a:ext uri="{FF2B5EF4-FFF2-40B4-BE49-F238E27FC236}">
-                <a16:creationId xmlns:a16="http://schemas.microsoft.com/office/drawing/2014/main" id="{5DDCB2DB-9EB5-4649-ACDE-920FAF70FC94}"/>
+                <a16:creationId xmlns:a16="http://schemas.microsoft.com/office/drawing/2014/main" id="{9C8C43E9-46F8-4568-93D6-EFB985944BDF}"/>
               </a:ext>
             </a:extLst>
           </p:cNvPr>
@@ -5757,7 +5857,7 @@
           <p:cNvPr id="15" name="">
             <a:extLst xmlns:a="http://schemas.openxmlformats.org/drawingml/2006/main">
               <a:ext uri="{FF2B5EF4-FFF2-40B4-BE49-F238E27FC236}">
-                <a16:creationId xmlns:a16="http://schemas.microsoft.com/office/drawing/2014/main" id="{F2AE99F2-FC6F-41A7-839C-80D93A8BAC4C}"/>
+                <a16:creationId xmlns:a16="http://schemas.microsoft.com/office/drawing/2014/main" id="{4CB92BF2-5D46-40A8-8853-02618477E344}"/>
               </a:ext>
             </a:extLst>
           </p:cNvPr>
@@ -5807,7 +5907,7 @@
           <p:cNvPr id="16" name="">
             <a:extLst xmlns:a="http://schemas.openxmlformats.org/drawingml/2006/main">
               <a:ext uri="{FF2B5EF4-FFF2-40B4-BE49-F238E27FC236}">
-                <a16:creationId xmlns:a16="http://schemas.microsoft.com/office/drawing/2014/main" id="{ABD37DCE-8475-40F7-BF13-9634D4B0CCAE}"/>
+                <a16:creationId xmlns:a16="http://schemas.microsoft.com/office/drawing/2014/main" id="{4570DB42-C937-43BB-89BD-4E05BB391646}"/>
               </a:ext>
             </a:extLst>
           </p:cNvPr>
@@ -5857,7 +5957,7 @@
           <p:cNvPr id="17" name="">
             <a:extLst xmlns:a="http://schemas.openxmlformats.org/drawingml/2006/main">
               <a:ext uri="{FF2B5EF4-FFF2-40B4-BE49-F238E27FC236}">
-                <a16:creationId xmlns:a16="http://schemas.microsoft.com/office/drawing/2014/main" id="{205F4616-1E1C-43D7-BB9E-EE68150C6E93}"/>
+                <a16:creationId xmlns:a16="http://schemas.microsoft.com/office/drawing/2014/main" id="{B42D0329-0E97-4B6A-824C-C49EAFF003FC}"/>
               </a:ext>
             </a:extLst>
           </p:cNvPr>
@@ -5905,7 +6005,7 @@
     </p:spTree>
     <p:extLst>
       <p:ext uri="{BB962C8B-B14F-4D97-AF65-F5344CB8AC3E}">
-        <p14:creationId xmlns:p14="http://schemas.microsoft.com/office/powerpoint/2010/main" val="1979484561"/>
+        <p14:creationId xmlns:p14="http://schemas.microsoft.com/office/powerpoint/2010/main" val="887377006"/>
       </p:ext>
     </p:extLst>
   </p:cSld>
@@ -5936,7 +6036,7 @@
           <p:cNvPr id="28" name="">
             <a:extLst xmlns:a="http://schemas.openxmlformats.org/drawingml/2006/main">
               <a:ext uri="{FF2B5EF4-FFF2-40B4-BE49-F238E27FC236}">
-                <a16:creationId xmlns:a16="http://schemas.microsoft.com/office/drawing/2014/main" id="{123544E3-146E-4B81-A06E-2E73B688D845}"/>
+                <a16:creationId xmlns:a16="http://schemas.microsoft.com/office/drawing/2014/main" id="{2071DE27-D0D3-429B-AA63-FE62E2C1BB3E}"/>
               </a:ext>
             </a:extLst>
           </p:cNvPr>
@@ -5986,7 +6086,7 @@
           <p:cNvPr id="2" name="">
             <a:extLst xmlns:a="http://schemas.openxmlformats.org/drawingml/2006/main">
               <a:ext uri="{FF2B5EF4-FFF2-40B4-BE49-F238E27FC236}">
-                <a16:creationId xmlns:a16="http://schemas.microsoft.com/office/drawing/2014/main" id="{A992C4DF-7BC1-4225-93CA-D05A37A8DC71}"/>
+                <a16:creationId xmlns:a16="http://schemas.microsoft.com/office/drawing/2014/main" id="{13C55EF6-80F4-46E1-9B50-39784D5E6868}"/>
               </a:ext>
             </a:extLst>
           </p:cNvPr>
@@ -6036,7 +6136,7 @@
           <p:cNvPr id="3" name="">
             <a:extLst xmlns:a="http://schemas.openxmlformats.org/drawingml/2006/main">
               <a:ext uri="{FF2B5EF4-FFF2-40B4-BE49-F238E27FC236}">
-                <a16:creationId xmlns:a16="http://schemas.microsoft.com/office/drawing/2014/main" id="{74D15914-9C87-481B-9F1E-851AFD684CE0}"/>
+                <a16:creationId xmlns:a16="http://schemas.microsoft.com/office/drawing/2014/main" id="{665BE1DC-7F33-4A4B-AC86-48ABF5545789}"/>
               </a:ext>
             </a:extLst>
           </p:cNvPr>
@@ -6067,7 +6167,7 @@
           <p:cNvPr id="4" name="">
             <a:extLst xmlns:a="http://schemas.openxmlformats.org/drawingml/2006/main">
               <a:ext uri="{FF2B5EF4-FFF2-40B4-BE49-F238E27FC236}">
-                <a16:creationId xmlns:a16="http://schemas.microsoft.com/office/drawing/2014/main" id="{C6C61E38-FE29-403E-94D4-3624EB6CA9F5}"/>
+                <a16:creationId xmlns:a16="http://schemas.microsoft.com/office/drawing/2014/main" id="{42C26AA3-D0C7-44C7-A108-5EB4B3722BE6}"/>
               </a:ext>
             </a:extLst>
           </p:cNvPr>
@@ -6117,7 +6217,7 @@
           <p:cNvPr id="5" name="">
             <a:extLst xmlns:a="http://schemas.openxmlformats.org/drawingml/2006/main">
               <a:ext uri="{FF2B5EF4-FFF2-40B4-BE49-F238E27FC236}">
-                <a16:creationId xmlns:a16="http://schemas.microsoft.com/office/drawing/2014/main" id="{16587A25-0136-4917-ADDF-E85E37220B95}"/>
+                <a16:creationId xmlns:a16="http://schemas.microsoft.com/office/drawing/2014/main" id="{A314D46C-2949-4552-A297-E70894273ED6}"/>
               </a:ext>
             </a:extLst>
           </p:cNvPr>
@@ -6167,7 +6267,7 @@
           <p:cNvPr id="6" name="">
             <a:extLst xmlns:a="http://schemas.openxmlformats.org/drawingml/2006/main">
               <a:ext uri="{FF2B5EF4-FFF2-40B4-BE49-F238E27FC236}">
-                <a16:creationId xmlns:a16="http://schemas.microsoft.com/office/drawing/2014/main" id="{6509BE52-83AF-47AD-80E3-F73615D0F376}"/>
+                <a16:creationId xmlns:a16="http://schemas.microsoft.com/office/drawing/2014/main" id="{D595BE51-F098-4700-B491-66EB976A4320}"/>
               </a:ext>
             </a:extLst>
           </p:cNvPr>
@@ -6198,7 +6298,7 @@
           <p:cNvPr id="7" name="">
             <a:extLst xmlns:a="http://schemas.openxmlformats.org/drawingml/2006/main">
               <a:ext uri="{FF2B5EF4-FFF2-40B4-BE49-F238E27FC236}">
-                <a16:creationId xmlns:a16="http://schemas.microsoft.com/office/drawing/2014/main" id="{88499E63-33ED-4EED-94D1-F3FC565AB44D}"/>
+                <a16:creationId xmlns:a16="http://schemas.microsoft.com/office/drawing/2014/main" id="{6319F876-9A93-43D6-8A3A-07EF10290340}"/>
               </a:ext>
             </a:extLst>
           </p:cNvPr>
@@ -6229,7 +6329,7 @@
           <p:cNvPr id="8" name="">
             <a:extLst xmlns:a="http://schemas.openxmlformats.org/drawingml/2006/main">
               <a:ext uri="{FF2B5EF4-FFF2-40B4-BE49-F238E27FC236}">
-                <a16:creationId xmlns:a16="http://schemas.microsoft.com/office/drawing/2014/main" id="{8E799D16-2786-4FB1-9A4F-37F969A37ACC}"/>
+                <a16:creationId xmlns:a16="http://schemas.microsoft.com/office/drawing/2014/main" id="{3966152B-9F1E-438E-BED9-3B01E20F0E67}"/>
               </a:ext>
             </a:extLst>
           </p:cNvPr>
@@ -6279,7 +6379,7 @@
           <p:cNvPr id="9" name="">
             <a:extLst xmlns:a="http://schemas.openxmlformats.org/drawingml/2006/main">
               <a:ext uri="{FF2B5EF4-FFF2-40B4-BE49-F238E27FC236}">
-                <a16:creationId xmlns:a16="http://schemas.microsoft.com/office/drawing/2014/main" id="{3CAEC795-CF19-447E-AA7D-0757B3ABC40C}"/>
+                <a16:creationId xmlns:a16="http://schemas.microsoft.com/office/drawing/2014/main" id="{D28C4802-E506-4F3B-9407-91176C35B68F}"/>
               </a:ext>
             </a:extLst>
           </p:cNvPr>
@@ -6329,7 +6429,7 @@
           <p:cNvPr id="10" name="">
             <a:extLst xmlns:a="http://schemas.openxmlformats.org/drawingml/2006/main">
               <a:ext uri="{FF2B5EF4-FFF2-40B4-BE49-F238E27FC236}">
-                <a16:creationId xmlns:a16="http://schemas.microsoft.com/office/drawing/2014/main" id="{4262193E-9A6C-4DF9-9984-64ECB62CA693}"/>
+                <a16:creationId xmlns:a16="http://schemas.microsoft.com/office/drawing/2014/main" id="{B3A64509-E8ED-4D48-B695-F8FC15839C75}"/>
               </a:ext>
             </a:extLst>
           </p:cNvPr>
@@ -6379,7 +6479,7 @@
           <p:cNvPr id="11" name="">
             <a:extLst xmlns:a="http://schemas.openxmlformats.org/drawingml/2006/main">
               <a:ext uri="{FF2B5EF4-FFF2-40B4-BE49-F238E27FC236}">
-                <a16:creationId xmlns:a16="http://schemas.microsoft.com/office/drawing/2014/main" id="{C4F0BE59-3231-429C-A9A6-81C1456413E3}"/>
+                <a16:creationId xmlns:a16="http://schemas.microsoft.com/office/drawing/2014/main" id="{E1464AF0-6122-40B1-B24E-708259BE34A7}"/>
               </a:ext>
             </a:extLst>
           </p:cNvPr>
@@ -6410,7 +6510,7 @@
           <p:cNvPr id="12" name="">
             <a:extLst xmlns:a="http://schemas.openxmlformats.org/drawingml/2006/main">
               <a:ext uri="{FF2B5EF4-FFF2-40B4-BE49-F238E27FC236}">
-                <a16:creationId xmlns:a16="http://schemas.microsoft.com/office/drawing/2014/main" id="{5B18CE02-2A96-4E68-A867-AD09963C873A}"/>
+                <a16:creationId xmlns:a16="http://schemas.microsoft.com/office/drawing/2014/main" id="{730331AF-4FD0-429C-84AC-50B51286975C}"/>
               </a:ext>
             </a:extLst>
           </p:cNvPr>
@@ -6441,7 +6541,7 @@
           <p:cNvPr id="13" name="">
             <a:extLst xmlns:a="http://schemas.openxmlformats.org/drawingml/2006/main">
               <a:ext uri="{FF2B5EF4-FFF2-40B4-BE49-F238E27FC236}">
-                <a16:creationId xmlns:a16="http://schemas.microsoft.com/office/drawing/2014/main" id="{2494688B-D983-438E-9C72-4F3A9D0BEB8E}"/>
+                <a16:creationId xmlns:a16="http://schemas.microsoft.com/office/drawing/2014/main" id="{332F9B5A-1DBF-4C82-B945-F638434FAF38}"/>
               </a:ext>
             </a:extLst>
           </p:cNvPr>
@@ -6491,7 +6591,7 @@
           <p:cNvPr id="14" name="">
             <a:extLst xmlns:a="http://schemas.openxmlformats.org/drawingml/2006/main">
               <a:ext uri="{FF2B5EF4-FFF2-40B4-BE49-F238E27FC236}">
-                <a16:creationId xmlns:a16="http://schemas.microsoft.com/office/drawing/2014/main" id="{1A1B87BD-F7B7-4BB0-B2D5-2F5F3A28BBA3}"/>
+                <a16:creationId xmlns:a16="http://schemas.microsoft.com/office/drawing/2014/main" id="{89DA4CDA-788F-4ED7-A124-C1258720654B}"/>
               </a:ext>
             </a:extLst>
           </p:cNvPr>
@@ -6541,7 +6641,7 @@
           <p:cNvPr id="15" name="">
             <a:extLst xmlns:a="http://schemas.openxmlformats.org/drawingml/2006/main">
               <a:ext uri="{FF2B5EF4-FFF2-40B4-BE49-F238E27FC236}">
-                <a16:creationId xmlns:a16="http://schemas.microsoft.com/office/drawing/2014/main" id="{54F3DFDE-DBCE-40F9-9857-DCB3368BAA1B}"/>
+                <a16:creationId xmlns:a16="http://schemas.microsoft.com/office/drawing/2014/main" id="{5E2AD3B5-62DA-4506-9527-294C00491E54}"/>
               </a:ext>
             </a:extLst>
           </p:cNvPr>
@@ -6591,7 +6691,7 @@
           <p:cNvPr id="16" name="">
             <a:extLst xmlns:a="http://schemas.openxmlformats.org/drawingml/2006/main">
               <a:ext uri="{FF2B5EF4-FFF2-40B4-BE49-F238E27FC236}">
-                <a16:creationId xmlns:a16="http://schemas.microsoft.com/office/drawing/2014/main" id="{F5DB292C-BB42-4082-9471-6E0B7C0CDD52}"/>
+                <a16:creationId xmlns:a16="http://schemas.microsoft.com/office/drawing/2014/main" id="{E4AC1FEB-76DF-4BB5-B567-3C1C6923681C}"/>
               </a:ext>
             </a:extLst>
           </p:cNvPr>
@@ -6622,7 +6722,7 @@
           <p:cNvPr id="17" name="">
             <a:extLst xmlns:a="http://schemas.openxmlformats.org/drawingml/2006/main">
               <a:ext uri="{FF2B5EF4-FFF2-40B4-BE49-F238E27FC236}">
-                <a16:creationId xmlns:a16="http://schemas.microsoft.com/office/drawing/2014/main" id="{2E771F0D-E0CC-4255-9764-A75C572963DF}"/>
+                <a16:creationId xmlns:a16="http://schemas.microsoft.com/office/drawing/2014/main" id="{009DFFA4-F658-497B-8A02-AB936D44A939}"/>
               </a:ext>
             </a:extLst>
           </p:cNvPr>
@@ -6653,7 +6753,7 @@
           <p:cNvPr id="18" name="">
             <a:extLst xmlns:a="http://schemas.openxmlformats.org/drawingml/2006/main">
               <a:ext uri="{FF2B5EF4-FFF2-40B4-BE49-F238E27FC236}">
-                <a16:creationId xmlns:a16="http://schemas.microsoft.com/office/drawing/2014/main" id="{80292CBE-06E9-4156-88DC-1A316C8E3B67}"/>
+                <a16:creationId xmlns:a16="http://schemas.microsoft.com/office/drawing/2014/main" id="{558D1FE4-36C7-495C-86CD-C8A6C9EB19E9}"/>
               </a:ext>
             </a:extLst>
           </p:cNvPr>
@@ -6703,7 +6803,7 @@
           <p:cNvPr id="19" name="">
             <a:extLst xmlns:a="http://schemas.openxmlformats.org/drawingml/2006/main">
               <a:ext uri="{FF2B5EF4-FFF2-40B4-BE49-F238E27FC236}">
-                <a16:creationId xmlns:a16="http://schemas.microsoft.com/office/drawing/2014/main" id="{76AD171F-2ADC-4661-9372-FB893106DDEF}"/>
+                <a16:creationId xmlns:a16="http://schemas.microsoft.com/office/drawing/2014/main" id="{2BCCB65F-5F3C-4C9A-BBDE-80018C1B0E22}"/>
               </a:ext>
             </a:extLst>
           </p:cNvPr>
@@ -6753,7 +6853,7 @@
           <p:cNvPr id="20" name="">
             <a:extLst xmlns:a="http://schemas.openxmlformats.org/drawingml/2006/main">
               <a:ext uri="{FF2B5EF4-FFF2-40B4-BE49-F238E27FC236}">
-                <a16:creationId xmlns:a16="http://schemas.microsoft.com/office/drawing/2014/main" id="{C1469856-59D9-46D3-97F1-642DB359CDF3}"/>
+                <a16:creationId xmlns:a16="http://schemas.microsoft.com/office/drawing/2014/main" id="{A83722E8-16D2-4EC8-85D4-C25BA2A58E43}"/>
               </a:ext>
             </a:extLst>
           </p:cNvPr>
@@ -6803,7 +6903,7 @@
           <p:cNvPr id="21" name="">
             <a:extLst xmlns:a="http://schemas.openxmlformats.org/drawingml/2006/main">
               <a:ext uri="{FF2B5EF4-FFF2-40B4-BE49-F238E27FC236}">
-                <a16:creationId xmlns:a16="http://schemas.microsoft.com/office/drawing/2014/main" id="{12E0C9A2-3E48-4BD9-9270-DDCBCDAC388B}"/>
+                <a16:creationId xmlns:a16="http://schemas.microsoft.com/office/drawing/2014/main" id="{1501356C-8AE0-4553-BA41-2F9F2B9BF1A1}"/>
               </a:ext>
             </a:extLst>
           </p:cNvPr>
@@ -6834,7 +6934,7 @@
           <p:cNvPr id="22" name="">
             <a:extLst xmlns:a="http://schemas.openxmlformats.org/drawingml/2006/main">
               <a:ext uri="{FF2B5EF4-FFF2-40B4-BE49-F238E27FC236}">
-                <a16:creationId xmlns:a16="http://schemas.microsoft.com/office/drawing/2014/main" id="{58D4C535-5CAD-494B-9563-C5F08D65280E}"/>
+                <a16:creationId xmlns:a16="http://schemas.microsoft.com/office/drawing/2014/main" id="{A27B1758-8794-4015-9D10-A21246A8BD34}"/>
               </a:ext>
             </a:extLst>
           </p:cNvPr>
@@ -6865,7 +6965,7 @@
           <p:cNvPr id="23" name="">
             <a:extLst xmlns:a="http://schemas.openxmlformats.org/drawingml/2006/main">
               <a:ext uri="{FF2B5EF4-FFF2-40B4-BE49-F238E27FC236}">
-                <a16:creationId xmlns:a16="http://schemas.microsoft.com/office/drawing/2014/main" id="{7A56E0EC-9426-448F-AECA-90FAAA940AD9}"/>
+                <a16:creationId xmlns:a16="http://schemas.microsoft.com/office/drawing/2014/main" id="{31FEED2C-261C-490C-A6CD-F23A0124D922}"/>
               </a:ext>
             </a:extLst>
           </p:cNvPr>
@@ -6915,7 +7015,7 @@
           <p:cNvPr id="24" name="">
             <a:extLst xmlns:a="http://schemas.openxmlformats.org/drawingml/2006/main">
               <a:ext uri="{FF2B5EF4-FFF2-40B4-BE49-F238E27FC236}">
-                <a16:creationId xmlns:a16="http://schemas.microsoft.com/office/drawing/2014/main" id="{44E54014-3111-42E7-8442-4A9B2A87ADA1}"/>
+                <a16:creationId xmlns:a16="http://schemas.microsoft.com/office/drawing/2014/main" id="{00BF7357-63D4-435A-BA66-43DD16D02D81}"/>
               </a:ext>
             </a:extLst>
           </p:cNvPr>
@@ -6946,7 +7046,7 @@
           <p:cNvPr id="25" name="">
             <a:extLst xmlns:a="http://schemas.openxmlformats.org/drawingml/2006/main">
               <a:ext uri="{FF2B5EF4-FFF2-40B4-BE49-F238E27FC236}">
-                <a16:creationId xmlns:a16="http://schemas.microsoft.com/office/drawing/2014/main" id="{51B003A1-3407-46BE-A727-676AF51AE88D}"/>
+                <a16:creationId xmlns:a16="http://schemas.microsoft.com/office/drawing/2014/main" id="{1EEF822A-744A-40B6-ABC8-6F6D44572591}"/>
               </a:ext>
             </a:extLst>
           </p:cNvPr>
@@ -6996,7 +7096,7 @@
           <p:cNvPr id="26" name="">
             <a:extLst xmlns:a="http://schemas.openxmlformats.org/drawingml/2006/main">
               <a:ext uri="{FF2B5EF4-FFF2-40B4-BE49-F238E27FC236}">
-                <a16:creationId xmlns:a16="http://schemas.microsoft.com/office/drawing/2014/main" id="{7C5EFFF9-3F34-445B-91ED-F37E0C08178F}"/>
+                <a16:creationId xmlns:a16="http://schemas.microsoft.com/office/drawing/2014/main" id="{BE07638C-F144-44D5-80F0-26D3F177235E}"/>
               </a:ext>
             </a:extLst>
           </p:cNvPr>
@@ -7046,7 +7146,7 @@
           <p:cNvPr id="27" name="">
             <a:extLst xmlns:a="http://schemas.openxmlformats.org/drawingml/2006/main">
               <a:ext uri="{FF2B5EF4-FFF2-40B4-BE49-F238E27FC236}">
-                <a16:creationId xmlns:a16="http://schemas.microsoft.com/office/drawing/2014/main" id="{45F5C19A-E74D-46D7-BE80-509296B3F6BA}"/>
+                <a16:creationId xmlns:a16="http://schemas.microsoft.com/office/drawing/2014/main" id="{A4CBFFB2-C7B4-442D-A21F-2ADCE8A0C70B}"/>
               </a:ext>
             </a:extLst>
           </p:cNvPr>
@@ -7094,7 +7194,7 @@
     </p:spTree>
     <p:extLst>
       <p:ext uri="{BB962C8B-B14F-4D97-AF65-F5344CB8AC3E}">
-        <p14:creationId xmlns:p14="http://schemas.microsoft.com/office/powerpoint/2010/main" val="186443616"/>
+        <p14:creationId xmlns:p14="http://schemas.microsoft.com/office/powerpoint/2010/main" val="891005609"/>
       </p:ext>
     </p:extLst>
   </p:cSld>
@@ -7125,7 +7225,7 @@
           <p:cNvPr id="21" name="">
             <a:extLst xmlns:a="http://schemas.openxmlformats.org/drawingml/2006/main">
               <a:ext uri="{FF2B5EF4-FFF2-40B4-BE49-F238E27FC236}">
-                <a16:creationId xmlns:a16="http://schemas.microsoft.com/office/drawing/2014/main" id="{134B4708-66A0-4971-BBA7-9E418C955D06}"/>
+                <a16:creationId xmlns:a16="http://schemas.microsoft.com/office/drawing/2014/main" id="{8F3FBB43-CEA1-42D7-889D-866EC550CF08}"/>
               </a:ext>
             </a:extLst>
           </p:cNvPr>
@@ -7175,7 +7275,7 @@
           <p:cNvPr id="2" name="">
             <a:extLst xmlns:a="http://schemas.openxmlformats.org/drawingml/2006/main">
               <a:ext uri="{FF2B5EF4-FFF2-40B4-BE49-F238E27FC236}">
-                <a16:creationId xmlns:a16="http://schemas.microsoft.com/office/drawing/2014/main" id="{979FB7D7-71E3-4165-835A-85B85F543DF3}"/>
+                <a16:creationId xmlns:a16="http://schemas.microsoft.com/office/drawing/2014/main" id="{C1412EC0-8402-476C-B103-31C510271F63}"/>
               </a:ext>
             </a:extLst>
           </p:cNvPr>
@@ -7225,7 +7325,7 @@
           <p:cNvPr id="3" name="">
             <a:extLst xmlns:a="http://schemas.openxmlformats.org/drawingml/2006/main">
               <a:ext uri="{FF2B5EF4-FFF2-40B4-BE49-F238E27FC236}">
-                <a16:creationId xmlns:a16="http://schemas.microsoft.com/office/drawing/2014/main" id="{5DBEDB6E-D2B3-43F3-8AEA-30257D59E8C9}"/>
+                <a16:creationId xmlns:a16="http://schemas.microsoft.com/office/drawing/2014/main" id="{58C17B50-74AB-4C55-9839-DD076A834376}"/>
               </a:ext>
             </a:extLst>
           </p:cNvPr>
@@ -7256,7 +7356,7 @@
           <p:cNvPr id="4" name="">
             <a:extLst xmlns:a="http://schemas.openxmlformats.org/drawingml/2006/main">
               <a:ext uri="{FF2B5EF4-FFF2-40B4-BE49-F238E27FC236}">
-                <a16:creationId xmlns:a16="http://schemas.microsoft.com/office/drawing/2014/main" id="{3588EA64-4835-4137-A723-6B7A885A2554}"/>
+                <a16:creationId xmlns:a16="http://schemas.microsoft.com/office/drawing/2014/main" id="{CB1B1DBF-7BA6-4928-BBA5-D56566DA6FD1}"/>
               </a:ext>
             </a:extLst>
           </p:cNvPr>
@@ -7306,7 +7406,7 @@
           <p:cNvPr id="5" name="">
             <a:extLst xmlns:a="http://schemas.openxmlformats.org/drawingml/2006/main">
               <a:ext uri="{FF2B5EF4-FFF2-40B4-BE49-F238E27FC236}">
-                <a16:creationId xmlns:a16="http://schemas.microsoft.com/office/drawing/2014/main" id="{292E419C-1178-473E-B6C4-5EB4D00D416A}"/>
+                <a16:creationId xmlns:a16="http://schemas.microsoft.com/office/drawing/2014/main" id="{30AC4B73-3DC3-4F80-81F7-DDA287140A98}"/>
               </a:ext>
             </a:extLst>
           </p:cNvPr>
@@ -7356,7 +7456,7 @@
           <p:cNvPr id="6" name="">
             <a:extLst xmlns:a="http://schemas.openxmlformats.org/drawingml/2006/main">
               <a:ext uri="{FF2B5EF4-FFF2-40B4-BE49-F238E27FC236}">
-                <a16:creationId xmlns:a16="http://schemas.microsoft.com/office/drawing/2014/main" id="{2C1CA6E6-998A-4B11-A453-CCBB0CFFEBA3}"/>
+                <a16:creationId xmlns:a16="http://schemas.microsoft.com/office/drawing/2014/main" id="{CFD2A92B-2F92-47EA-9456-B145D25C40C2}"/>
               </a:ext>
             </a:extLst>
           </p:cNvPr>
@@ -7406,7 +7506,7 @@
           <p:cNvPr id="7" name="">
             <a:extLst xmlns:a="http://schemas.openxmlformats.org/drawingml/2006/main">
               <a:ext uri="{FF2B5EF4-FFF2-40B4-BE49-F238E27FC236}">
-                <a16:creationId xmlns:a16="http://schemas.microsoft.com/office/drawing/2014/main" id="{4FC6BCAE-BE4D-45B9-AB76-2B617AFB5D55}"/>
+                <a16:creationId xmlns:a16="http://schemas.microsoft.com/office/drawing/2014/main" id="{FC2B654A-F774-4640-9CAE-4F398ED3E609}"/>
               </a:ext>
             </a:extLst>
           </p:cNvPr>
@@ -7456,7 +7556,7 @@
           <p:cNvPr id="8" name="">
             <a:extLst xmlns:a="http://schemas.openxmlformats.org/drawingml/2006/main">
               <a:ext uri="{FF2B5EF4-FFF2-40B4-BE49-F238E27FC236}">
-                <a16:creationId xmlns:a16="http://schemas.microsoft.com/office/drawing/2014/main" id="{2F75459A-EE66-4E87-B280-A6A85ABBA728}"/>
+                <a16:creationId xmlns:a16="http://schemas.microsoft.com/office/drawing/2014/main" id="{183637DC-79A2-49DA-953D-F0DB9A30E3B1}"/>
               </a:ext>
             </a:extLst>
           </p:cNvPr>
@@ -7487,7 +7587,7 @@
           <p:cNvPr id="9" name="">
             <a:extLst xmlns:a="http://schemas.openxmlformats.org/drawingml/2006/main">
               <a:ext uri="{FF2B5EF4-FFF2-40B4-BE49-F238E27FC236}">
-                <a16:creationId xmlns:a16="http://schemas.microsoft.com/office/drawing/2014/main" id="{ECFBB6F5-26A3-4D22-83EF-FC6426DEAC7E}"/>
+                <a16:creationId xmlns:a16="http://schemas.microsoft.com/office/drawing/2014/main" id="{BFE9A71C-C9B6-4AF4-ABAC-C82BE63872CB}"/>
               </a:ext>
             </a:extLst>
           </p:cNvPr>
@@ -7537,7 +7637,7 @@
           <p:cNvPr id="10" name="">
             <a:extLst xmlns:a="http://schemas.openxmlformats.org/drawingml/2006/main">
               <a:ext uri="{FF2B5EF4-FFF2-40B4-BE49-F238E27FC236}">
-                <a16:creationId xmlns:a16="http://schemas.microsoft.com/office/drawing/2014/main" id="{1B22ED4A-3EBD-4DA8-9F1B-20124F44E567}"/>
+                <a16:creationId xmlns:a16="http://schemas.microsoft.com/office/drawing/2014/main" id="{7863E6E7-B32D-4FC9-BFA8-2794DE772E42}"/>
               </a:ext>
             </a:extLst>
           </p:cNvPr>
@@ -7587,7 +7687,7 @@
           <p:cNvPr id="11" name="">
             <a:extLst xmlns:a="http://schemas.openxmlformats.org/drawingml/2006/main">
               <a:ext uri="{FF2B5EF4-FFF2-40B4-BE49-F238E27FC236}">
-                <a16:creationId xmlns:a16="http://schemas.microsoft.com/office/drawing/2014/main" id="{A714B805-ED68-4F5A-88CF-0FECCF0F8342}"/>
+                <a16:creationId xmlns:a16="http://schemas.microsoft.com/office/drawing/2014/main" id="{5B8CAD45-A13F-43EC-9181-23C20B22BF0B}"/>
               </a:ext>
             </a:extLst>
           </p:cNvPr>
@@ -7637,7 +7737,7 @@
           <p:cNvPr id="12" name="">
             <a:extLst xmlns:a="http://schemas.openxmlformats.org/drawingml/2006/main">
               <a:ext uri="{FF2B5EF4-FFF2-40B4-BE49-F238E27FC236}">
-                <a16:creationId xmlns:a16="http://schemas.microsoft.com/office/drawing/2014/main" id="{2B679C34-C2AF-414C-9020-6187D2AAD534}"/>
+                <a16:creationId xmlns:a16="http://schemas.microsoft.com/office/drawing/2014/main" id="{C42248C6-5707-4FA8-B12B-BB94C3427791}"/>
               </a:ext>
             </a:extLst>
           </p:cNvPr>
@@ -7687,7 +7787,7 @@
           <p:cNvPr id="13" name="">
             <a:extLst xmlns:a="http://schemas.openxmlformats.org/drawingml/2006/main">
               <a:ext uri="{FF2B5EF4-FFF2-40B4-BE49-F238E27FC236}">
-                <a16:creationId xmlns:a16="http://schemas.microsoft.com/office/drawing/2014/main" id="{C273EA46-2EAA-4ED7-A3CC-E4CD720ED11D}"/>
+                <a16:creationId xmlns:a16="http://schemas.microsoft.com/office/drawing/2014/main" id="{8C6BCB23-1888-44F4-889E-5E4DC6523B7B}"/>
               </a:ext>
             </a:extLst>
           </p:cNvPr>
@@ -7718,7 +7818,7 @@
           <p:cNvPr id="14" name="">
             <a:extLst xmlns:a="http://schemas.openxmlformats.org/drawingml/2006/main">
               <a:ext uri="{FF2B5EF4-FFF2-40B4-BE49-F238E27FC236}">
-                <a16:creationId xmlns:a16="http://schemas.microsoft.com/office/drawing/2014/main" id="{ED89BE47-16C7-46E4-A6C4-855C0712356A}"/>
+                <a16:creationId xmlns:a16="http://schemas.microsoft.com/office/drawing/2014/main" id="{69AB2F58-4005-4F4A-9F4F-D5B8452D9ADF}"/>
               </a:ext>
             </a:extLst>
           </p:cNvPr>
@@ -7768,7 +7868,7 @@
           <p:cNvPr id="15" name="">
             <a:extLst xmlns:a="http://schemas.openxmlformats.org/drawingml/2006/main">
               <a:ext uri="{FF2B5EF4-FFF2-40B4-BE49-F238E27FC236}">
-                <a16:creationId xmlns:a16="http://schemas.microsoft.com/office/drawing/2014/main" id="{D9D3B857-870B-4434-B027-F2B8002FC818}"/>
+                <a16:creationId xmlns:a16="http://schemas.microsoft.com/office/drawing/2014/main" id="{CA18D9B0-BECC-4067-AB8E-5460849D13DA}"/>
               </a:ext>
             </a:extLst>
           </p:cNvPr>
@@ -7818,7 +7918,7 @@
           <p:cNvPr id="16" name="">
             <a:extLst xmlns:a="http://schemas.openxmlformats.org/drawingml/2006/main">
               <a:ext uri="{FF2B5EF4-FFF2-40B4-BE49-F238E27FC236}">
-                <a16:creationId xmlns:a16="http://schemas.microsoft.com/office/drawing/2014/main" id="{5E99047D-772B-4AB3-8F74-A88A442491C9}"/>
+                <a16:creationId xmlns:a16="http://schemas.microsoft.com/office/drawing/2014/main" id="{A0844855-2622-40A2-B24D-9F7BE2C74A6C}"/>
               </a:ext>
             </a:extLst>
           </p:cNvPr>
@@ -7868,7 +7968,7 @@
           <p:cNvPr id="17" name="">
             <a:extLst xmlns:a="http://schemas.openxmlformats.org/drawingml/2006/main">
               <a:ext uri="{FF2B5EF4-FFF2-40B4-BE49-F238E27FC236}">
-                <a16:creationId xmlns:a16="http://schemas.microsoft.com/office/drawing/2014/main" id="{53F4D7C9-1E82-4DF9-A38F-27F9593E370E}"/>
+                <a16:creationId xmlns:a16="http://schemas.microsoft.com/office/drawing/2014/main" id="{AF6CE690-7207-4444-B6F6-124AE6109EEA}"/>
               </a:ext>
             </a:extLst>
           </p:cNvPr>
@@ -7918,7 +8018,7 @@
           <p:cNvPr id="18" name="">
             <a:extLst xmlns:a="http://schemas.openxmlformats.org/drawingml/2006/main">
               <a:ext uri="{FF2B5EF4-FFF2-40B4-BE49-F238E27FC236}">
-                <a16:creationId xmlns:a16="http://schemas.microsoft.com/office/drawing/2014/main" id="{93A0DAAC-F377-4588-80B7-9FCB0745C810}"/>
+                <a16:creationId xmlns:a16="http://schemas.microsoft.com/office/drawing/2014/main" id="{94FB6395-8571-48F6-9F5B-291A8A8D2C5A}"/>
               </a:ext>
             </a:extLst>
           </p:cNvPr>
@@ -7968,7 +8068,7 @@
           <p:cNvPr id="19" name="">
             <a:extLst xmlns:a="http://schemas.openxmlformats.org/drawingml/2006/main">
               <a:ext uri="{FF2B5EF4-FFF2-40B4-BE49-F238E27FC236}">
-                <a16:creationId xmlns:a16="http://schemas.microsoft.com/office/drawing/2014/main" id="{ACC23D89-0ECC-474D-AA66-2F6416798EAA}"/>
+                <a16:creationId xmlns:a16="http://schemas.microsoft.com/office/drawing/2014/main" id="{AD8BC576-7B88-4FF7-BC4C-34CED873E5AA}"/>
               </a:ext>
             </a:extLst>
           </p:cNvPr>
@@ -8018,7 +8118,7 @@
           <p:cNvPr id="20" name="">
             <a:extLst xmlns:a="http://schemas.openxmlformats.org/drawingml/2006/main">
               <a:ext uri="{FF2B5EF4-FFF2-40B4-BE49-F238E27FC236}">
-                <a16:creationId xmlns:a16="http://schemas.microsoft.com/office/drawing/2014/main" id="{20ADBDB0-D2DB-4E74-A26B-3FB280F3C593}"/>
+                <a16:creationId xmlns:a16="http://schemas.microsoft.com/office/drawing/2014/main" id="{7BA3F6A1-2298-4AD4-9114-ECD10EB52FD6}"/>
               </a:ext>
             </a:extLst>
           </p:cNvPr>
@@ -8066,7 +8166,7 @@
     </p:spTree>
     <p:extLst>
       <p:ext uri="{BB962C8B-B14F-4D97-AF65-F5344CB8AC3E}">
-        <p14:creationId xmlns:p14="http://schemas.microsoft.com/office/powerpoint/2010/main" val="603200185"/>
+        <p14:creationId xmlns:p14="http://schemas.microsoft.com/office/powerpoint/2010/main" val="798280540"/>
       </p:ext>
     </p:extLst>
   </p:cSld>
@@ -8097,7 +8197,7 @@
           <p:cNvPr id="22" name="">
             <a:extLst xmlns:a="http://schemas.openxmlformats.org/drawingml/2006/main">
               <a:ext uri="{FF2B5EF4-FFF2-40B4-BE49-F238E27FC236}">
-                <a16:creationId xmlns:a16="http://schemas.microsoft.com/office/drawing/2014/main" id="{4D06D8B0-C81A-4017-9290-8D7CE563B8B1}"/>
+                <a16:creationId xmlns:a16="http://schemas.microsoft.com/office/drawing/2014/main" id="{CFBD1F26-A905-40B1-AD24-BF848F9ED84C}"/>
               </a:ext>
             </a:extLst>
           </p:cNvPr>
@@ -8147,7 +8247,7 @@
           <p:cNvPr id="2" name="">
             <a:extLst xmlns:a="http://schemas.openxmlformats.org/drawingml/2006/main">
               <a:ext uri="{FF2B5EF4-FFF2-40B4-BE49-F238E27FC236}">
-                <a16:creationId xmlns:a16="http://schemas.microsoft.com/office/drawing/2014/main" id="{6B29E42E-C07F-4968-AC04-19FC22768989}"/>
+                <a16:creationId xmlns:a16="http://schemas.microsoft.com/office/drawing/2014/main" id="{0687E946-B492-4195-87DC-E45CE4894BBA}"/>
               </a:ext>
             </a:extLst>
           </p:cNvPr>
@@ -8197,7 +8297,7 @@
           <p:cNvPr id="3" name="">
             <a:extLst xmlns:a="http://schemas.openxmlformats.org/drawingml/2006/main">
               <a:ext uri="{FF2B5EF4-FFF2-40B4-BE49-F238E27FC236}">
-                <a16:creationId xmlns:a16="http://schemas.microsoft.com/office/drawing/2014/main" id="{24C0B60B-F46D-4B1E-8867-CAE7AAE055E5}"/>
+                <a16:creationId xmlns:a16="http://schemas.microsoft.com/office/drawing/2014/main" id="{A956F20F-12DE-4A19-BE66-CB1AA77727AB}"/>
               </a:ext>
             </a:extLst>
           </p:cNvPr>
@@ -8228,7 +8328,7 @@
           <p:cNvPr id="4" name="">
             <a:extLst xmlns:a="http://schemas.openxmlformats.org/drawingml/2006/main">
               <a:ext uri="{FF2B5EF4-FFF2-40B4-BE49-F238E27FC236}">
-                <a16:creationId xmlns:a16="http://schemas.microsoft.com/office/drawing/2014/main" id="{7CB6CEC0-BCD2-4C23-A0E5-9A9AEBF6784C}"/>
+                <a16:creationId xmlns:a16="http://schemas.microsoft.com/office/drawing/2014/main" id="{2175AB12-6FC4-40B1-A52A-78663792D67B}"/>
               </a:ext>
             </a:extLst>
           </p:cNvPr>
@@ -8278,7 +8378,7 @@
           <p:cNvPr id="5" name="">
             <a:extLst xmlns:a="http://schemas.openxmlformats.org/drawingml/2006/main">
               <a:ext uri="{FF2B5EF4-FFF2-40B4-BE49-F238E27FC236}">
-                <a16:creationId xmlns:a16="http://schemas.microsoft.com/office/drawing/2014/main" id="{F99B0002-9072-475E-ADA5-99F087CCB8BE}"/>
+                <a16:creationId xmlns:a16="http://schemas.microsoft.com/office/drawing/2014/main" id="{AE64E2C0-EAEA-46A5-8FDF-824B778225E4}"/>
               </a:ext>
             </a:extLst>
           </p:cNvPr>
@@ -8328,7 +8428,7 @@
           <p:cNvPr id="6" name="">
             <a:extLst xmlns:a="http://schemas.openxmlformats.org/drawingml/2006/main">
               <a:ext uri="{FF2B5EF4-FFF2-40B4-BE49-F238E27FC236}">
-                <a16:creationId xmlns:a16="http://schemas.microsoft.com/office/drawing/2014/main" id="{D3B8DD2E-23DC-433C-A655-6614042AFF74}"/>
+                <a16:creationId xmlns:a16="http://schemas.microsoft.com/office/drawing/2014/main" id="{0C986E95-EC5B-44A0-B985-82FBFE1636B4}"/>
               </a:ext>
             </a:extLst>
           </p:cNvPr>
@@ -8378,7 +8478,7 @@
           <p:cNvPr id="7" name="">
             <a:extLst xmlns:a="http://schemas.openxmlformats.org/drawingml/2006/main">
               <a:ext uri="{FF2B5EF4-FFF2-40B4-BE49-F238E27FC236}">
-                <a16:creationId xmlns:a16="http://schemas.microsoft.com/office/drawing/2014/main" id="{C2BA82AD-C858-41E4-9058-73E69051A162}"/>
+                <a16:creationId xmlns:a16="http://schemas.microsoft.com/office/drawing/2014/main" id="{A2A1587E-020A-4158-AD42-4586073D8A92}"/>
               </a:ext>
             </a:extLst>
           </p:cNvPr>
@@ -8428,7 +8528,7 @@
           <p:cNvPr id="8" name="">
             <a:extLst xmlns:a="http://schemas.openxmlformats.org/drawingml/2006/main">
               <a:ext uri="{FF2B5EF4-FFF2-40B4-BE49-F238E27FC236}">
-                <a16:creationId xmlns:a16="http://schemas.microsoft.com/office/drawing/2014/main" id="{1FA63657-4C97-4834-9C35-8E47E15A5236}"/>
+                <a16:creationId xmlns:a16="http://schemas.microsoft.com/office/drawing/2014/main" id="{4154DAAA-5D05-44A8-85D9-3ECAF7CD2DB3}"/>
               </a:ext>
             </a:extLst>
           </p:cNvPr>
@@ -8478,7 +8578,7 @@
           <p:cNvPr id="9" name="">
             <a:extLst xmlns:a="http://schemas.openxmlformats.org/drawingml/2006/main">
               <a:ext uri="{FF2B5EF4-FFF2-40B4-BE49-F238E27FC236}">
-                <a16:creationId xmlns:a16="http://schemas.microsoft.com/office/drawing/2014/main" id="{CFE0D2FA-C2BF-47FF-A3C1-713FBD2ED0FB}"/>
+                <a16:creationId xmlns:a16="http://schemas.microsoft.com/office/drawing/2014/main" id="{6CB67E4C-16A8-43D0-88D0-C9B3BB56DF21}"/>
               </a:ext>
             </a:extLst>
           </p:cNvPr>
@@ -8528,7 +8628,7 @@
           <p:cNvPr id="10" name="">
             <a:extLst xmlns:a="http://schemas.openxmlformats.org/drawingml/2006/main">
               <a:ext uri="{FF2B5EF4-FFF2-40B4-BE49-F238E27FC236}">
-                <a16:creationId xmlns:a16="http://schemas.microsoft.com/office/drawing/2014/main" id="{CCF1A9E7-5A52-4566-9492-26CB25D02E30}"/>
+                <a16:creationId xmlns:a16="http://schemas.microsoft.com/office/drawing/2014/main" id="{8DD1A1D5-E67E-402F-A694-CFC0390F4E18}"/>
               </a:ext>
             </a:extLst>
           </p:cNvPr>
@@ -8559,7 +8659,7 @@
           <p:cNvPr id="11" name="">
             <a:extLst xmlns:a="http://schemas.openxmlformats.org/drawingml/2006/main">
               <a:ext uri="{FF2B5EF4-FFF2-40B4-BE49-F238E27FC236}">
-                <a16:creationId xmlns:a16="http://schemas.microsoft.com/office/drawing/2014/main" id="{8D636F23-42C4-4934-836B-F59314D6ED13}"/>
+                <a16:creationId xmlns:a16="http://schemas.microsoft.com/office/drawing/2014/main" id="{BE024CD9-315A-4F9A-9489-48031BA194DC}"/>
               </a:ext>
             </a:extLst>
           </p:cNvPr>
@@ -8609,7 +8709,7 @@
           <p:cNvPr id="12" name="">
             <a:extLst xmlns:a="http://schemas.openxmlformats.org/drawingml/2006/main">
               <a:ext uri="{FF2B5EF4-FFF2-40B4-BE49-F238E27FC236}">
-                <a16:creationId xmlns:a16="http://schemas.microsoft.com/office/drawing/2014/main" id="{6F5F820F-A3FF-44C9-9486-1AB17C566269}"/>
+                <a16:creationId xmlns:a16="http://schemas.microsoft.com/office/drawing/2014/main" id="{F1906FCD-432E-4123-A371-E0438B64A557}"/>
               </a:ext>
             </a:extLst>
           </p:cNvPr>
@@ -8659,7 +8759,7 @@
           <p:cNvPr id="13" name="">
             <a:extLst xmlns:a="http://schemas.openxmlformats.org/drawingml/2006/main">
               <a:ext uri="{FF2B5EF4-FFF2-40B4-BE49-F238E27FC236}">
-                <a16:creationId xmlns:a16="http://schemas.microsoft.com/office/drawing/2014/main" id="{0A6D6318-2728-4360-8D00-D82821F6687A}"/>
+                <a16:creationId xmlns:a16="http://schemas.microsoft.com/office/drawing/2014/main" id="{C5023FF8-5710-423B-935A-360B71CCE095}"/>
               </a:ext>
             </a:extLst>
           </p:cNvPr>
@@ -8690,7 +8790,7 @@
           <p:cNvPr id="14" name="">
             <a:extLst xmlns:a="http://schemas.openxmlformats.org/drawingml/2006/main">
               <a:ext uri="{FF2B5EF4-FFF2-40B4-BE49-F238E27FC236}">
-                <a16:creationId xmlns:a16="http://schemas.microsoft.com/office/drawing/2014/main" id="{31090E57-C92D-44B9-BB7A-7B9FBFFD18CC}"/>
+                <a16:creationId xmlns:a16="http://schemas.microsoft.com/office/drawing/2014/main" id="{85FDA832-14A4-47C5-AB32-21FE5FEAE674}"/>
               </a:ext>
             </a:extLst>
           </p:cNvPr>
@@ -8740,7 +8840,7 @@
           <p:cNvPr id="15" name="">
             <a:extLst xmlns:a="http://schemas.openxmlformats.org/drawingml/2006/main">
               <a:ext uri="{FF2B5EF4-FFF2-40B4-BE49-F238E27FC236}">
-                <a16:creationId xmlns:a16="http://schemas.microsoft.com/office/drawing/2014/main" id="{A804C6F9-8156-4703-966E-53CAE424B2C2}"/>
+                <a16:creationId xmlns:a16="http://schemas.microsoft.com/office/drawing/2014/main" id="{2BF63017-629B-461F-9D45-3EDF18C97990}"/>
               </a:ext>
             </a:extLst>
           </p:cNvPr>
@@ -8824,7 +8924,7 @@
           <p:cNvPr id="16" name="">
             <a:extLst xmlns:a="http://schemas.openxmlformats.org/drawingml/2006/main">
               <a:ext uri="{FF2B5EF4-FFF2-40B4-BE49-F238E27FC236}">
-                <a16:creationId xmlns:a16="http://schemas.microsoft.com/office/drawing/2014/main" id="{2721BE8C-230E-4446-A44D-7FA28D990459}"/>
+                <a16:creationId xmlns:a16="http://schemas.microsoft.com/office/drawing/2014/main" id="{4CC4879B-33B3-4F4F-93CE-31E966E4894F}"/>
               </a:ext>
             </a:extLst>
           </p:cNvPr>
@@ -8874,7 +8974,7 @@
           <p:cNvPr id="17" name="">
             <a:extLst xmlns:a="http://schemas.openxmlformats.org/drawingml/2006/main">
               <a:ext uri="{FF2B5EF4-FFF2-40B4-BE49-F238E27FC236}">
-                <a16:creationId xmlns:a16="http://schemas.microsoft.com/office/drawing/2014/main" id="{170B5EBE-857A-4EFA-ACBF-9DDC7E412D93}"/>
+                <a16:creationId xmlns:a16="http://schemas.microsoft.com/office/drawing/2014/main" id="{9F34F37B-71B1-4905-AB5E-D11F55C2CAB3}"/>
               </a:ext>
             </a:extLst>
           </p:cNvPr>
@@ -8958,7 +9058,7 @@
           <p:cNvPr id="18" name="">
             <a:extLst xmlns:a="http://schemas.openxmlformats.org/drawingml/2006/main">
               <a:ext uri="{FF2B5EF4-FFF2-40B4-BE49-F238E27FC236}">
-                <a16:creationId xmlns:a16="http://schemas.microsoft.com/office/drawing/2014/main" id="{BF0A9AF6-B21C-4F92-A160-55A168DCB159}"/>
+                <a16:creationId xmlns:a16="http://schemas.microsoft.com/office/drawing/2014/main" id="{7E6DC66D-1081-4461-BE18-41448A1433B6}"/>
               </a:ext>
             </a:extLst>
           </p:cNvPr>
@@ -8989,7 +9089,7 @@
           <p:cNvPr id="19" name="">
             <a:extLst xmlns:a="http://schemas.openxmlformats.org/drawingml/2006/main">
               <a:ext uri="{FF2B5EF4-FFF2-40B4-BE49-F238E27FC236}">
-                <a16:creationId xmlns:a16="http://schemas.microsoft.com/office/drawing/2014/main" id="{05F36826-DED3-4AEC-BA34-871692E978E8}"/>
+                <a16:creationId xmlns:a16="http://schemas.microsoft.com/office/drawing/2014/main" id="{06481DDC-B7E3-4337-92D9-F7657A13BF08}"/>
               </a:ext>
             </a:extLst>
           </p:cNvPr>
@@ -9039,7 +9139,7 @@
           <p:cNvPr id="20" name="">
             <a:extLst xmlns:a="http://schemas.openxmlformats.org/drawingml/2006/main">
               <a:ext uri="{FF2B5EF4-FFF2-40B4-BE49-F238E27FC236}">
-                <a16:creationId xmlns:a16="http://schemas.microsoft.com/office/drawing/2014/main" id="{7A58EC9B-ACC5-4A29-AD01-7F210F33D1D1}"/>
+                <a16:creationId xmlns:a16="http://schemas.microsoft.com/office/drawing/2014/main" id="{4786A811-F6A3-4187-BC17-B7C9378D5DE0}"/>
               </a:ext>
             </a:extLst>
           </p:cNvPr>
@@ -9089,7 +9189,7 @@
           <p:cNvPr id="21" name="">
             <a:extLst xmlns:a="http://schemas.openxmlformats.org/drawingml/2006/main">
               <a:ext uri="{FF2B5EF4-FFF2-40B4-BE49-F238E27FC236}">
-                <a16:creationId xmlns:a16="http://schemas.microsoft.com/office/drawing/2014/main" id="{F6E64062-1D7D-41AE-B423-3F4EF75ADF4F}"/>
+                <a16:creationId xmlns:a16="http://schemas.microsoft.com/office/drawing/2014/main" id="{17429028-E7D7-4F3A-8C60-425BF698493D}"/>
               </a:ext>
             </a:extLst>
           </p:cNvPr>
@@ -9137,7 +9237,7 @@
     </p:spTree>
     <p:extLst>
       <p:ext uri="{BB962C8B-B14F-4D97-AF65-F5344CB8AC3E}">
-        <p14:creationId xmlns:p14="http://schemas.microsoft.com/office/powerpoint/2010/main" val="2067333542"/>
+        <p14:creationId xmlns:p14="http://schemas.microsoft.com/office/powerpoint/2010/main" val="776510825"/>
       </p:ext>
     </p:extLst>
   </p:cSld>
@@ -9168,7 +9268,7 @@
           <p:cNvPr id="10" name="">
             <a:extLst xmlns:a="http://schemas.openxmlformats.org/drawingml/2006/main">
               <a:ext uri="{FF2B5EF4-FFF2-40B4-BE49-F238E27FC236}">
-                <a16:creationId xmlns:a16="http://schemas.microsoft.com/office/drawing/2014/main" id="{88319D9C-0C0A-44B8-95C4-2D9886C0879C}"/>
+                <a16:creationId xmlns:a16="http://schemas.microsoft.com/office/drawing/2014/main" id="{4953C5FC-258E-4D1D-A748-9D6817CC7940}"/>
               </a:ext>
             </a:extLst>
           </p:cNvPr>
@@ -9218,7 +9318,7 @@
           <p:cNvPr id="2" name="">
             <a:extLst xmlns:a="http://schemas.openxmlformats.org/drawingml/2006/main">
               <a:ext uri="{FF2B5EF4-FFF2-40B4-BE49-F238E27FC236}">
-                <a16:creationId xmlns:a16="http://schemas.microsoft.com/office/drawing/2014/main" id="{E0F5B869-48F5-4767-933C-5BB8E732679F}"/>
+                <a16:creationId xmlns:a16="http://schemas.microsoft.com/office/drawing/2014/main" id="{B4FBFD55-0A08-4B9D-8CF1-000E8C24D4F8}"/>
               </a:ext>
             </a:extLst>
           </p:cNvPr>
@@ -9302,7 +9402,7 @@
           <p:cNvPr id="3" name="">
             <a:extLst xmlns:a="http://schemas.openxmlformats.org/drawingml/2006/main">
               <a:ext uri="{FF2B5EF4-FFF2-40B4-BE49-F238E27FC236}">
-                <a16:creationId xmlns:a16="http://schemas.microsoft.com/office/drawing/2014/main" id="{54DFE242-FC84-4B85-8D9B-CD5F0092244A}"/>
+                <a16:creationId xmlns:a16="http://schemas.microsoft.com/office/drawing/2014/main" id="{BFA0F6DD-7DE5-4035-9F86-DFE5C484B602}"/>
               </a:ext>
             </a:extLst>
           </p:cNvPr>
@@ -9333,7 +9433,7 @@
           <p:cNvPr id="4" name="">
             <a:extLst xmlns:a="http://schemas.openxmlformats.org/drawingml/2006/main">
               <a:ext uri="{FF2B5EF4-FFF2-40B4-BE49-F238E27FC236}">
-                <a16:creationId xmlns:a16="http://schemas.microsoft.com/office/drawing/2014/main" id="{E497B5BF-0951-46A0-857D-A2EFB6984FAE}"/>
+                <a16:creationId xmlns:a16="http://schemas.microsoft.com/office/drawing/2014/main" id="{3F7991F2-EFA1-4058-9122-7538134E071A}"/>
               </a:ext>
             </a:extLst>
           </p:cNvPr>
@@ -9400,7 +9500,7 @@
           <p:cNvPr id="5" name="">
             <a:extLst xmlns:a="http://schemas.openxmlformats.org/drawingml/2006/main">
               <a:ext uri="{FF2B5EF4-FFF2-40B4-BE49-F238E27FC236}">
-                <a16:creationId xmlns:a16="http://schemas.microsoft.com/office/drawing/2014/main" id="{EE6E2449-9009-4059-BF66-02C2CCA20E09}"/>
+                <a16:creationId xmlns:a16="http://schemas.microsoft.com/office/drawing/2014/main" id="{253EBF36-B378-42B9-876D-52C2ED46BFD1}"/>
               </a:ext>
             </a:extLst>
           </p:cNvPr>
@@ -9431,7 +9531,7 @@
           <p:cNvPr id="6" name="">
             <a:extLst xmlns:a="http://schemas.openxmlformats.org/drawingml/2006/main">
               <a:ext uri="{FF2B5EF4-FFF2-40B4-BE49-F238E27FC236}">
-                <a16:creationId xmlns:a16="http://schemas.microsoft.com/office/drawing/2014/main" id="{5A8E4BD4-396D-4A44-80ED-89AD3D72939C}"/>
+                <a16:creationId xmlns:a16="http://schemas.microsoft.com/office/drawing/2014/main" id="{043104D5-CEE2-4434-813A-BF885D909B7D}"/>
               </a:ext>
             </a:extLst>
           </p:cNvPr>
@@ -9481,7 +9581,7 @@
           <p:cNvPr id="7" name="">
             <a:extLst xmlns:a="http://schemas.openxmlformats.org/drawingml/2006/main">
               <a:ext uri="{FF2B5EF4-FFF2-40B4-BE49-F238E27FC236}">
-                <a16:creationId xmlns:a16="http://schemas.microsoft.com/office/drawing/2014/main" id="{EB86E630-E28C-48A6-A43A-1789067D64FA}"/>
+                <a16:creationId xmlns:a16="http://schemas.microsoft.com/office/drawing/2014/main" id="{7589364B-1AC4-4D7B-8F9F-672970EF88B2}"/>
               </a:ext>
             </a:extLst>
           </p:cNvPr>
@@ -9531,7 +9631,7 @@
           <p:cNvPr id="8" name="">
             <a:extLst xmlns:a="http://schemas.openxmlformats.org/drawingml/2006/main">
               <a:ext uri="{FF2B5EF4-FFF2-40B4-BE49-F238E27FC236}">
-                <a16:creationId xmlns:a16="http://schemas.microsoft.com/office/drawing/2014/main" id="{F241408F-328F-41FC-A0DD-6785678F2258}"/>
+                <a16:creationId xmlns:a16="http://schemas.microsoft.com/office/drawing/2014/main" id="{CDBB25B3-C053-49DB-9AE0-BED109FB20BF}"/>
               </a:ext>
             </a:extLst>
           </p:cNvPr>
@@ -9581,7 +9681,7 @@
           <p:cNvPr id="9" name="">
             <a:extLst xmlns:a="http://schemas.openxmlformats.org/drawingml/2006/main">
               <a:ext uri="{FF2B5EF4-FFF2-40B4-BE49-F238E27FC236}">
-                <a16:creationId xmlns:a16="http://schemas.microsoft.com/office/drawing/2014/main" id="{B289835C-B34E-48E8-965F-2D3E86A841A1}"/>
+                <a16:creationId xmlns:a16="http://schemas.microsoft.com/office/drawing/2014/main" id="{CA7B52A0-D4D5-4587-886A-1AD1AAACC5E9}"/>
               </a:ext>
             </a:extLst>
           </p:cNvPr>
@@ -9629,7 +9729,7 @@
     </p:spTree>
     <p:extLst>
       <p:ext uri="{BB962C8B-B14F-4D97-AF65-F5344CB8AC3E}">
-        <p14:creationId xmlns:p14="http://schemas.microsoft.com/office/powerpoint/2010/main" val="1446006045"/>
+        <p14:creationId xmlns:p14="http://schemas.microsoft.com/office/powerpoint/2010/main" val="2132495868"/>
       </p:ext>
     </p:extLst>
   </p:cSld>

</xml_diff>